<commit_message>
On branch main  Changes to be committed: 	modified:   automation/export_ppt.py 	modified:   dataconfig/data.py 	modified:   dataconfig/mapping.py 	modified:   main.py 	modified:   template/query_templates.py 	modified:   template/template_infografis.pptx 	new file:   template/template_infografis_old.pptx
</commit_message>
<xml_diff>
--- a/template/template_infografis.pptx
+++ b/template/template_infografis.pptx
@@ -18531,1060 +18531,6 @@
           </a:p>
         </p:txBody>
       </p:sp>
-      <p:graphicFrame>
-        <p:nvGraphicFramePr>
-          <p:cNvPr id="768" name="table_1"/>
-          <p:cNvGraphicFramePr/>
-          <p:nvPr>
-            <p:extLst>
-              <p:ext uri="{D42A27DB-BD31-4B8C-83A1-F6EECF244321}">
-                <p14:modId xmlns:p14="http://schemas.microsoft.com/office/powerpoint/2010/main" val="2981174713"/>
-              </p:ext>
-            </p:extLst>
-          </p:nvPr>
-        </p:nvGraphicFramePr>
-        <p:xfrm>
-          <a:off x="414412" y="3193380"/>
-          <a:ext cx="1527850" cy="1850390"/>
-        </p:xfrm>
-        <a:graphic>
-          <a:graphicData uri="http://schemas.openxmlformats.org/drawingml/2006/table">
-            <a:tbl>
-              <a:tblPr>
-                <a:noFill/>
-                <a:tableStyleId>{2460487B-A31E-4291-9FF1-7AE1C1612F53}</a:tableStyleId>
-              </a:tblPr>
-              <a:tblGrid>
-                <a:gridCol w="674900">
-                  <a:extLst>
-                    <a:ext uri="{9D8B030D-6E8A-4147-A177-3AD203B41FA5}">
-                      <a16:colId xmlns:a16="http://schemas.microsoft.com/office/drawing/2014/main" val="20000"/>
-                    </a:ext>
-                  </a:extLst>
-                </a:gridCol>
-                <a:gridCol w="852950">
-                  <a:extLst>
-                    <a:ext uri="{9D8B030D-6E8A-4147-A177-3AD203B41FA5}">
-                      <a16:colId xmlns:a16="http://schemas.microsoft.com/office/drawing/2014/main" val="20001"/>
-                    </a:ext>
-                  </a:extLst>
-                </a:gridCol>
-              </a:tblGrid>
-              <a:tr h="123275">
-                <a:tc>
-                  <a:txBody>
-                    <a:bodyPr/>
-                    <a:lstStyle/>
-                    <a:p>
-                      <a:pPr marL="0" marR="0" lvl="0" indent="0" algn="l" rtl="0">
-                        <a:lnSpc>
-                          <a:spcPct val="100000"/>
-                        </a:lnSpc>
-                        <a:spcBef>
-                          <a:spcPts val="0"/>
-                        </a:spcBef>
-                        <a:spcAft>
-                          <a:spcPts val="0"/>
-                        </a:spcAft>
-                        <a:buNone/>
-                      </a:pPr>
-                      <a:r>
-                        <a:rPr lang="id" sz="1000" b="0" i="0" u="none" strike="noStrike" cap="none" dirty="0">
-                          <a:solidFill>
-                            <a:srgbClr val="000000"/>
-                          </a:solidFill>
-                          <a:latin typeface="Arial"/>
-                          <a:ea typeface="Arial"/>
-                          <a:cs typeface="Arial"/>
-                          <a:sym typeface="Arial"/>
-                        </a:rPr>
-                        <a:t> 0 -</a:t>
-                      </a:r>
-                      <a:r>
-                        <a:rPr lang="en-US" sz="1000" b="0" i="0" u="none" strike="noStrike" cap="none" dirty="0">
-                          <a:solidFill>
-                            <a:srgbClr val="000000"/>
-                          </a:solidFill>
-                          <a:latin typeface="Arial"/>
-                          <a:ea typeface="Arial"/>
-                          <a:cs typeface="Arial"/>
-                          <a:sym typeface="Arial"/>
-                        </a:rPr>
-                        <a:t> </a:t>
-                      </a:r>
-                      <a:r>
-                        <a:rPr lang="id" sz="1000" b="0" i="0" u="none" strike="noStrike" cap="none" dirty="0">
-                          <a:solidFill>
-                            <a:srgbClr val="000000"/>
-                          </a:solidFill>
-                          <a:latin typeface="Arial"/>
-                          <a:ea typeface="Arial"/>
-                          <a:cs typeface="Arial"/>
-                          <a:sym typeface="Arial"/>
-                        </a:rPr>
-                        <a:t>5</a:t>
-                      </a:r>
-                      <a:endParaRPr sz="1000" dirty="0"/>
-                    </a:p>
-                  </a:txBody>
-                  <a:tcPr marL="3800" marR="3800" marT="0" marB="0" anchor="ctr">
-                    <a:lnL w="9525" cap="flat" cmpd="sng">
-                      <a:solidFill>
-                        <a:schemeClr val="lt1"/>
-                      </a:solidFill>
-                      <a:prstDash val="solid"/>
-                      <a:round/>
-                      <a:headEnd type="none" w="sm" len="sm"/>
-                      <a:tailEnd type="none" w="sm" len="sm"/>
-                    </a:lnL>
-                    <a:lnR w="9525" cap="flat" cmpd="sng" algn="ctr">
-                      <a:solidFill>
-                        <a:schemeClr val="lt1"/>
-                      </a:solidFill>
-                      <a:prstDash val="solid"/>
-                      <a:round/>
-                      <a:headEnd type="none" w="sm" len="sm"/>
-                      <a:tailEnd type="none" w="sm" len="sm"/>
-                    </a:lnR>
-                    <a:lnT w="9525" cap="flat" cmpd="sng">
-                      <a:solidFill>
-                        <a:schemeClr val="lt1"/>
-                      </a:solidFill>
-                      <a:prstDash val="solid"/>
-                      <a:round/>
-                      <a:headEnd type="none" w="sm" len="sm"/>
-                      <a:tailEnd type="none" w="sm" len="sm"/>
-                    </a:lnT>
-                    <a:lnB w="9525" cap="flat" cmpd="sng">
-                      <a:solidFill>
-                        <a:schemeClr val="lt1"/>
-                      </a:solidFill>
-                      <a:prstDash val="solid"/>
-                      <a:round/>
-                      <a:headEnd type="none" w="sm" len="sm"/>
-                      <a:tailEnd type="none" w="sm" len="sm"/>
-                    </a:lnB>
-                    <a:solidFill>
-                      <a:srgbClr val="BAF8FF"/>
-                    </a:solidFill>
-                  </a:tcPr>
-                </a:tc>
-                <a:tc>
-                  <a:txBody>
-                    <a:bodyPr/>
-                    <a:lstStyle/>
-                    <a:p>
-                      <a:pPr algn="r" fontAlgn="b"/>
-                      <a:r>
-                        <a:rPr lang="en-US" sz="1100" b="0" i="0" u="none" strike="noStrike" dirty="0">
-                          <a:solidFill>
-                            <a:srgbClr val="000000"/>
-                          </a:solidFill>
-                          <a:effectLst/>
-                          <a:latin typeface="Calibri" panose="020F0502020204030204" pitchFamily="34" charset="0"/>
-                        </a:rPr>
-                        <a:t>{count_0_5}</a:t>
-                      </a:r>
-                    </a:p>
-                  </a:txBody>
-                  <a:tcPr marL="6350" marR="6350" marT="6350" marB="0" anchor="b">
-                    <a:lnL w="9525" cap="flat" cmpd="sng">
-                      <a:solidFill>
-                        <a:schemeClr val="lt1"/>
-                      </a:solidFill>
-                      <a:prstDash val="solid"/>
-                      <a:round/>
-                      <a:headEnd type="none" w="sm" len="sm"/>
-                      <a:tailEnd type="none" w="sm" len="sm"/>
-                    </a:lnL>
-                    <a:lnR w="9525" cap="flat" cmpd="sng">
-                      <a:solidFill>
-                        <a:schemeClr val="lt1"/>
-                      </a:solidFill>
-                      <a:prstDash val="solid"/>
-                      <a:round/>
-                      <a:headEnd type="none" w="sm" len="sm"/>
-                      <a:tailEnd type="none" w="sm" len="sm"/>
-                    </a:lnR>
-                    <a:lnT w="9525" cap="flat" cmpd="sng">
-                      <a:solidFill>
-                        <a:schemeClr val="lt1"/>
-                      </a:solidFill>
-                      <a:prstDash val="solid"/>
-                      <a:round/>
-                      <a:headEnd type="none" w="sm" len="sm"/>
-                      <a:tailEnd type="none" w="sm" len="sm"/>
-                    </a:lnT>
-                    <a:lnB w="9525" cap="flat" cmpd="sng" algn="ctr">
-                      <a:solidFill>
-                        <a:schemeClr val="lt1"/>
-                      </a:solidFill>
-                      <a:prstDash val="solid"/>
-                      <a:round/>
-                      <a:headEnd type="none" w="sm" len="sm"/>
-                      <a:tailEnd type="none" w="sm" len="sm"/>
-                    </a:lnB>
-                    <a:solidFill>
-                      <a:srgbClr val="BAF8FF"/>
-                    </a:solidFill>
-                  </a:tcPr>
-                </a:tc>
-                <a:extLst>
-                  <a:ext uri="{0D108BD9-81ED-4DB2-BD59-A6C34878D82A}">
-                    <a16:rowId xmlns:a16="http://schemas.microsoft.com/office/drawing/2014/main" val="10000"/>
-                  </a:ext>
-                </a:extLst>
-              </a:tr>
-              <a:tr h="123275">
-                <a:tc>
-                  <a:txBody>
-                    <a:bodyPr/>
-                    <a:lstStyle/>
-                    <a:p>
-                      <a:pPr marL="0" marR="0" lvl="0" indent="0" algn="l" rtl="0">
-                        <a:lnSpc>
-                          <a:spcPct val="100000"/>
-                        </a:lnSpc>
-                        <a:spcBef>
-                          <a:spcPts val="0"/>
-                        </a:spcBef>
-                        <a:spcAft>
-                          <a:spcPts val="0"/>
-                        </a:spcAft>
-                        <a:buNone/>
-                      </a:pPr>
-                      <a:r>
-                        <a:rPr lang="id" sz="1000" b="0" i="0" u="none" strike="noStrike" cap="none" dirty="0">
-                          <a:solidFill>
-                            <a:srgbClr val="000000"/>
-                          </a:solidFill>
-                          <a:latin typeface="Arial"/>
-                          <a:ea typeface="Arial"/>
-                          <a:cs typeface="Arial"/>
-                          <a:sym typeface="Arial"/>
-                        </a:rPr>
-                        <a:t> 6 - 10</a:t>
-                      </a:r>
-                      <a:endParaRPr sz="1000" dirty="0"/>
-                    </a:p>
-                  </a:txBody>
-                  <a:tcPr marL="3800" marR="3800" marT="0" marB="0" anchor="ctr">
-                    <a:lnL w="9525" cap="flat" cmpd="sng">
-                      <a:solidFill>
-                        <a:schemeClr val="lt1"/>
-                      </a:solidFill>
-                      <a:prstDash val="solid"/>
-                      <a:round/>
-                      <a:headEnd type="none" w="sm" len="sm"/>
-                      <a:tailEnd type="none" w="sm" len="sm"/>
-                    </a:lnL>
-                    <a:lnR w="9525" cap="flat" cmpd="sng" algn="ctr">
-                      <a:solidFill>
-                        <a:schemeClr val="lt1"/>
-                      </a:solidFill>
-                      <a:prstDash val="solid"/>
-                      <a:round/>
-                      <a:headEnd type="none" w="sm" len="sm"/>
-                      <a:tailEnd type="none" w="sm" len="sm"/>
-                    </a:lnR>
-                    <a:lnT w="9525" cap="flat" cmpd="sng">
-                      <a:solidFill>
-                        <a:schemeClr val="lt1"/>
-                      </a:solidFill>
-                      <a:prstDash val="solid"/>
-                      <a:round/>
-                      <a:headEnd type="none" w="sm" len="sm"/>
-                      <a:tailEnd type="none" w="sm" len="sm"/>
-                    </a:lnT>
-                    <a:lnB w="9525" cap="flat" cmpd="sng">
-                      <a:solidFill>
-                        <a:schemeClr val="lt1"/>
-                      </a:solidFill>
-                      <a:prstDash val="solid"/>
-                      <a:round/>
-                      <a:headEnd type="none" w="sm" len="sm"/>
-                      <a:tailEnd type="none" w="sm" len="sm"/>
-                    </a:lnB>
-                    <a:solidFill>
-                      <a:srgbClr val="BAF8FF"/>
-                    </a:solidFill>
-                  </a:tcPr>
-                </a:tc>
-                <a:tc>
-                  <a:txBody>
-                    <a:bodyPr/>
-                    <a:lstStyle/>
-                    <a:p>
-                      <a:pPr algn="r" fontAlgn="b"/>
-                      <a:r>
-                        <a:rPr lang="en-US" sz="1100" b="0" i="0" u="none" strike="noStrike" dirty="0">
-                          <a:solidFill>
-                            <a:srgbClr val="000000"/>
-                          </a:solidFill>
-                          <a:effectLst/>
-                          <a:latin typeface="Calibri" panose="020F0502020204030204" pitchFamily="34" charset="0"/>
-                        </a:rPr>
-                        <a:t>{count_6_10}</a:t>
-                      </a:r>
-                    </a:p>
-                  </a:txBody>
-                  <a:tcPr marL="7620" marR="7620" marT="0" marB="0" anchor="b">
-                    <a:lnL w="9525" cap="flat" cmpd="sng">
-                      <a:solidFill>
-                        <a:schemeClr val="lt1"/>
-                      </a:solidFill>
-                      <a:prstDash val="solid"/>
-                      <a:round/>
-                      <a:headEnd type="none" w="sm" len="sm"/>
-                      <a:tailEnd type="none" w="sm" len="sm"/>
-                    </a:lnL>
-                    <a:lnR w="9525" cap="flat" cmpd="sng">
-                      <a:solidFill>
-                        <a:schemeClr val="lt1"/>
-                      </a:solidFill>
-                      <a:prstDash val="solid"/>
-                      <a:round/>
-                      <a:headEnd type="none" w="sm" len="sm"/>
-                      <a:tailEnd type="none" w="sm" len="sm"/>
-                    </a:lnR>
-                    <a:lnT w="9525" cap="flat" cmpd="sng" algn="ctr">
-                      <a:solidFill>
-                        <a:schemeClr val="lt1"/>
-                      </a:solidFill>
-                      <a:prstDash val="solid"/>
-                      <a:round/>
-                      <a:headEnd type="none" w="sm" len="sm"/>
-                      <a:tailEnd type="none" w="sm" len="sm"/>
-                    </a:lnT>
-                    <a:lnB w="9525" cap="flat" cmpd="sng" algn="ctr">
-                      <a:solidFill>
-                        <a:schemeClr val="lt1"/>
-                      </a:solidFill>
-                      <a:prstDash val="solid"/>
-                      <a:round/>
-                      <a:headEnd type="none" w="sm" len="sm"/>
-                      <a:tailEnd type="none" w="sm" len="sm"/>
-                    </a:lnB>
-                    <a:solidFill>
-                      <a:srgbClr val="BAF8FF"/>
-                    </a:solidFill>
-                  </a:tcPr>
-                </a:tc>
-                <a:extLst>
-                  <a:ext uri="{0D108BD9-81ED-4DB2-BD59-A6C34878D82A}">
-                    <a16:rowId xmlns:a16="http://schemas.microsoft.com/office/drawing/2014/main" val="10001"/>
-                  </a:ext>
-                </a:extLst>
-              </a:tr>
-              <a:tr h="123275">
-                <a:tc>
-                  <a:txBody>
-                    <a:bodyPr/>
-                    <a:lstStyle/>
-                    <a:p>
-                      <a:pPr marL="0" marR="0" lvl="0" indent="0" algn="l" rtl="0">
-                        <a:lnSpc>
-                          <a:spcPct val="100000"/>
-                        </a:lnSpc>
-                        <a:spcBef>
-                          <a:spcPts val="0"/>
-                        </a:spcBef>
-                        <a:spcAft>
-                          <a:spcPts val="0"/>
-                        </a:spcAft>
-                        <a:buNone/>
-                      </a:pPr>
-                      <a:r>
-                        <a:rPr lang="id" sz="1000" b="0" i="0" u="none" strike="noStrike" cap="none" dirty="0">
-                          <a:solidFill>
-                            <a:srgbClr val="000000"/>
-                          </a:solidFill>
-                          <a:latin typeface="Arial"/>
-                          <a:ea typeface="Arial"/>
-                          <a:cs typeface="Arial"/>
-                          <a:sym typeface="Arial"/>
-                        </a:rPr>
-                        <a:t>11 - 15</a:t>
-                      </a:r>
-                      <a:endParaRPr sz="1000" dirty="0"/>
-                    </a:p>
-                  </a:txBody>
-                  <a:tcPr marL="3800" marR="3800" marT="0" marB="0" anchor="ctr">
-                    <a:lnL w="9525" cap="flat" cmpd="sng">
-                      <a:solidFill>
-                        <a:schemeClr val="lt1"/>
-                      </a:solidFill>
-                      <a:prstDash val="solid"/>
-                      <a:round/>
-                      <a:headEnd type="none" w="sm" len="sm"/>
-                      <a:tailEnd type="none" w="sm" len="sm"/>
-                    </a:lnL>
-                    <a:lnR w="9525" cap="flat" cmpd="sng" algn="ctr">
-                      <a:solidFill>
-                        <a:schemeClr val="lt1"/>
-                      </a:solidFill>
-                      <a:prstDash val="solid"/>
-                      <a:round/>
-                      <a:headEnd type="none" w="sm" len="sm"/>
-                      <a:tailEnd type="none" w="sm" len="sm"/>
-                    </a:lnR>
-                    <a:lnT w="9525" cap="flat" cmpd="sng">
-                      <a:solidFill>
-                        <a:schemeClr val="lt1"/>
-                      </a:solidFill>
-                      <a:prstDash val="solid"/>
-                      <a:round/>
-                      <a:headEnd type="none" w="sm" len="sm"/>
-                      <a:tailEnd type="none" w="sm" len="sm"/>
-                    </a:lnT>
-                    <a:lnB w="9525" cap="flat" cmpd="sng">
-                      <a:solidFill>
-                        <a:schemeClr val="lt1"/>
-                      </a:solidFill>
-                      <a:prstDash val="solid"/>
-                      <a:round/>
-                      <a:headEnd type="none" w="sm" len="sm"/>
-                      <a:tailEnd type="none" w="sm" len="sm"/>
-                    </a:lnB>
-                    <a:solidFill>
-                      <a:srgbClr val="BAF8FF"/>
-                    </a:solidFill>
-                  </a:tcPr>
-                </a:tc>
-                <a:tc>
-                  <a:txBody>
-                    <a:bodyPr/>
-                    <a:lstStyle/>
-                    <a:p>
-                      <a:pPr algn="r" fontAlgn="b"/>
-                      <a:r>
-                        <a:rPr lang="en-US" sz="1100" b="0" i="0" u="none" strike="noStrike" dirty="0">
-                          <a:solidFill>
-                            <a:srgbClr val="000000"/>
-                          </a:solidFill>
-                          <a:effectLst/>
-                          <a:latin typeface="Calibri" panose="020F0502020204030204" pitchFamily="34" charset="0"/>
-                        </a:rPr>
-                        <a:t>{count_11_15}</a:t>
-                      </a:r>
-                    </a:p>
-                  </a:txBody>
-                  <a:tcPr marL="7620" marR="7620" marT="0" marB="0" anchor="b">
-                    <a:lnL w="9525" cap="flat" cmpd="sng">
-                      <a:solidFill>
-                        <a:schemeClr val="lt1"/>
-                      </a:solidFill>
-                      <a:prstDash val="solid"/>
-                      <a:round/>
-                      <a:headEnd type="none" w="sm" len="sm"/>
-                      <a:tailEnd type="none" w="sm" len="sm"/>
-                    </a:lnL>
-                    <a:lnR w="9525" cap="flat" cmpd="sng">
-                      <a:solidFill>
-                        <a:schemeClr val="lt1"/>
-                      </a:solidFill>
-                      <a:prstDash val="solid"/>
-                      <a:round/>
-                      <a:headEnd type="none" w="sm" len="sm"/>
-                      <a:tailEnd type="none" w="sm" len="sm"/>
-                    </a:lnR>
-                    <a:lnT w="9525" cap="flat" cmpd="sng" algn="ctr">
-                      <a:solidFill>
-                        <a:schemeClr val="lt1"/>
-                      </a:solidFill>
-                      <a:prstDash val="solid"/>
-                      <a:round/>
-                      <a:headEnd type="none" w="sm" len="sm"/>
-                      <a:tailEnd type="none" w="sm" len="sm"/>
-                    </a:lnT>
-                    <a:lnB w="9525" cap="flat" cmpd="sng">
-                      <a:solidFill>
-                        <a:schemeClr val="lt1"/>
-                      </a:solidFill>
-                      <a:prstDash val="solid"/>
-                      <a:round/>
-                      <a:headEnd type="none" w="sm" len="sm"/>
-                      <a:tailEnd type="none" w="sm" len="sm"/>
-                    </a:lnB>
-                    <a:solidFill>
-                      <a:srgbClr val="BAF8FF"/>
-                    </a:solidFill>
-                  </a:tcPr>
-                </a:tc>
-                <a:extLst>
-                  <a:ext uri="{0D108BD9-81ED-4DB2-BD59-A6C34878D82A}">
-                    <a16:rowId xmlns:a16="http://schemas.microsoft.com/office/drawing/2014/main" val="10002"/>
-                  </a:ext>
-                </a:extLst>
-              </a:tr>
-              <a:tr h="123275">
-                <a:tc>
-                  <a:txBody>
-                    <a:bodyPr/>
-                    <a:lstStyle/>
-                    <a:p>
-                      <a:pPr marL="0" marR="0" lvl="0" indent="0" algn="l" rtl="0">
-                        <a:lnSpc>
-                          <a:spcPct val="100000"/>
-                        </a:lnSpc>
-                        <a:spcBef>
-                          <a:spcPts val="0"/>
-                        </a:spcBef>
-                        <a:spcAft>
-                          <a:spcPts val="0"/>
-                        </a:spcAft>
-                        <a:buNone/>
-                      </a:pPr>
-                      <a:r>
-                        <a:rPr lang="id" sz="1000" b="0" i="0" u="none" strike="noStrike" cap="none">
-                          <a:solidFill>
-                            <a:srgbClr val="000000"/>
-                          </a:solidFill>
-                          <a:latin typeface="Arial"/>
-                          <a:ea typeface="Arial"/>
-                          <a:cs typeface="Arial"/>
-                          <a:sym typeface="Arial"/>
-                        </a:rPr>
-                        <a:t>16 - 20</a:t>
-                      </a:r>
-                      <a:endParaRPr sz="1000"/>
-                    </a:p>
-                  </a:txBody>
-                  <a:tcPr marL="3800" marR="3800" marT="0" marB="0" anchor="ctr">
-                    <a:lnL w="9525" cap="flat" cmpd="sng">
-                      <a:solidFill>
-                        <a:schemeClr val="lt1"/>
-                      </a:solidFill>
-                      <a:prstDash val="solid"/>
-                      <a:round/>
-                      <a:headEnd type="none" w="sm" len="sm"/>
-                      <a:tailEnd type="none" w="sm" len="sm"/>
-                    </a:lnL>
-                    <a:lnR w="9525" cap="flat" cmpd="sng" algn="ctr">
-                      <a:solidFill>
-                        <a:schemeClr val="lt1"/>
-                      </a:solidFill>
-                      <a:prstDash val="solid"/>
-                      <a:round/>
-                      <a:headEnd type="none" w="sm" len="sm"/>
-                      <a:tailEnd type="none" w="sm" len="sm"/>
-                    </a:lnR>
-                    <a:lnT w="9525" cap="flat" cmpd="sng">
-                      <a:solidFill>
-                        <a:schemeClr val="lt1"/>
-                      </a:solidFill>
-                      <a:prstDash val="solid"/>
-                      <a:round/>
-                      <a:headEnd type="none" w="sm" len="sm"/>
-                      <a:tailEnd type="none" w="sm" len="sm"/>
-                    </a:lnT>
-                    <a:lnB w="9525" cap="flat" cmpd="sng">
-                      <a:solidFill>
-                        <a:schemeClr val="lt1"/>
-                      </a:solidFill>
-                      <a:prstDash val="solid"/>
-                      <a:round/>
-                      <a:headEnd type="none" w="sm" len="sm"/>
-                      <a:tailEnd type="none" w="sm" len="sm"/>
-                    </a:lnB>
-                    <a:solidFill>
-                      <a:srgbClr val="BAF8FF"/>
-                    </a:solidFill>
-                  </a:tcPr>
-                </a:tc>
-                <a:tc>
-                  <a:txBody>
-                    <a:bodyPr/>
-                    <a:lstStyle/>
-                    <a:p>
-                      <a:pPr algn="r" fontAlgn="b"/>
-                      <a:r>
-                        <a:rPr lang="en-US" sz="1100" b="0" i="0" u="none" strike="noStrike" dirty="0">
-                          <a:solidFill>
-                            <a:srgbClr val="000000"/>
-                          </a:solidFill>
-                          <a:effectLst/>
-                          <a:latin typeface="Calibri" panose="020F0502020204030204" pitchFamily="34" charset="0"/>
-                        </a:rPr>
-                        <a:t>{count_16_20}</a:t>
-                      </a:r>
-                    </a:p>
-                  </a:txBody>
-                  <a:tcPr marL="7620" marR="7620" marT="0" marB="0" anchor="b">
-                    <a:lnL w="9525" cap="flat" cmpd="sng">
-                      <a:solidFill>
-                        <a:schemeClr val="lt1"/>
-                      </a:solidFill>
-                      <a:prstDash val="solid"/>
-                      <a:round/>
-                      <a:headEnd type="none" w="sm" len="sm"/>
-                      <a:tailEnd type="none" w="sm" len="sm"/>
-                    </a:lnL>
-                    <a:lnR w="9525" cap="flat" cmpd="sng">
-                      <a:solidFill>
-                        <a:schemeClr val="lt1"/>
-                      </a:solidFill>
-                      <a:prstDash val="solid"/>
-                      <a:round/>
-                      <a:headEnd type="none" w="sm" len="sm"/>
-                      <a:tailEnd type="none" w="sm" len="sm"/>
-                    </a:lnR>
-                    <a:lnT w="9525" cap="flat" cmpd="sng">
-                      <a:solidFill>
-                        <a:schemeClr val="lt1"/>
-                      </a:solidFill>
-                      <a:prstDash val="solid"/>
-                      <a:round/>
-                      <a:headEnd type="none" w="sm" len="sm"/>
-                      <a:tailEnd type="none" w="sm" len="sm"/>
-                    </a:lnT>
-                    <a:lnB w="9525" cap="flat" cmpd="sng">
-                      <a:solidFill>
-                        <a:schemeClr val="lt1"/>
-                      </a:solidFill>
-                      <a:prstDash val="solid"/>
-                      <a:round/>
-                      <a:headEnd type="none" w="sm" len="sm"/>
-                      <a:tailEnd type="none" w="sm" len="sm"/>
-                    </a:lnB>
-                    <a:solidFill>
-                      <a:srgbClr val="BAF8FF"/>
-                    </a:solidFill>
-                  </a:tcPr>
-                </a:tc>
-                <a:extLst>
-                  <a:ext uri="{0D108BD9-81ED-4DB2-BD59-A6C34878D82A}">
-                    <a16:rowId xmlns:a16="http://schemas.microsoft.com/office/drawing/2014/main" val="10003"/>
-                  </a:ext>
-                </a:extLst>
-              </a:tr>
-              <a:tr h="123275">
-                <a:tc>
-                  <a:txBody>
-                    <a:bodyPr/>
-                    <a:lstStyle/>
-                    <a:p>
-                      <a:pPr marL="0" marR="0" lvl="0" indent="0" algn="l" rtl="0">
-                        <a:lnSpc>
-                          <a:spcPct val="100000"/>
-                        </a:lnSpc>
-                        <a:spcBef>
-                          <a:spcPts val="0"/>
-                        </a:spcBef>
-                        <a:spcAft>
-                          <a:spcPts val="0"/>
-                        </a:spcAft>
-                        <a:buNone/>
-                      </a:pPr>
-                      <a:r>
-                        <a:rPr lang="id" sz="1000" b="0" i="0" u="none" strike="noStrike" cap="none">
-                          <a:solidFill>
-                            <a:srgbClr val="000000"/>
-                          </a:solidFill>
-                          <a:latin typeface="Arial"/>
-                          <a:ea typeface="Arial"/>
-                          <a:cs typeface="Arial"/>
-                          <a:sym typeface="Arial"/>
-                        </a:rPr>
-                        <a:t>21 - 25</a:t>
-                      </a:r>
-                      <a:endParaRPr sz="1000"/>
-                    </a:p>
-                  </a:txBody>
-                  <a:tcPr marL="3800" marR="3800" marT="0" marB="0" anchor="ctr">
-                    <a:lnL w="9525" cap="flat" cmpd="sng">
-                      <a:solidFill>
-                        <a:schemeClr val="lt1"/>
-                      </a:solidFill>
-                      <a:prstDash val="solid"/>
-                      <a:round/>
-                      <a:headEnd type="none" w="sm" len="sm"/>
-                      <a:tailEnd type="none" w="sm" len="sm"/>
-                    </a:lnL>
-                    <a:lnR w="9525" cap="flat" cmpd="sng" algn="ctr">
-                      <a:solidFill>
-                        <a:schemeClr val="lt1"/>
-                      </a:solidFill>
-                      <a:prstDash val="solid"/>
-                      <a:round/>
-                      <a:headEnd type="none" w="sm" len="sm"/>
-                      <a:tailEnd type="none" w="sm" len="sm"/>
-                    </a:lnR>
-                    <a:lnT w="9525" cap="flat" cmpd="sng">
-                      <a:solidFill>
-                        <a:schemeClr val="lt1"/>
-                      </a:solidFill>
-                      <a:prstDash val="solid"/>
-                      <a:round/>
-                      <a:headEnd type="none" w="sm" len="sm"/>
-                      <a:tailEnd type="none" w="sm" len="sm"/>
-                    </a:lnT>
-                    <a:lnB w="9525" cap="flat" cmpd="sng">
-                      <a:solidFill>
-                        <a:schemeClr val="lt1"/>
-                      </a:solidFill>
-                      <a:prstDash val="solid"/>
-                      <a:round/>
-                      <a:headEnd type="none" w="sm" len="sm"/>
-                      <a:tailEnd type="none" w="sm" len="sm"/>
-                    </a:lnB>
-                    <a:solidFill>
-                      <a:srgbClr val="BAF8FF"/>
-                    </a:solidFill>
-                  </a:tcPr>
-                </a:tc>
-                <a:tc>
-                  <a:txBody>
-                    <a:bodyPr/>
-                    <a:lstStyle/>
-                    <a:p>
-                      <a:pPr algn="r" fontAlgn="b"/>
-                      <a:r>
-                        <a:rPr lang="en-US" sz="1100" b="0" i="0" u="none" strike="noStrike" dirty="0">
-                          <a:solidFill>
-                            <a:srgbClr val="000000"/>
-                          </a:solidFill>
-                          <a:effectLst/>
-                          <a:latin typeface="Calibri" panose="020F0502020204030204" pitchFamily="34" charset="0"/>
-                        </a:rPr>
-                        <a:t>{count_21_25}</a:t>
-                      </a:r>
-                    </a:p>
-                  </a:txBody>
-                  <a:tcPr marL="7620" marR="7620" marT="0" marB="0" anchor="b">
-                    <a:lnL w="9525" cap="flat" cmpd="sng">
-                      <a:solidFill>
-                        <a:schemeClr val="lt1"/>
-                      </a:solidFill>
-                      <a:prstDash val="solid"/>
-                      <a:round/>
-                      <a:headEnd type="none" w="sm" len="sm"/>
-                      <a:tailEnd type="none" w="sm" len="sm"/>
-                    </a:lnL>
-                    <a:lnR w="9525" cap="flat" cmpd="sng">
-                      <a:solidFill>
-                        <a:schemeClr val="lt1"/>
-                      </a:solidFill>
-                      <a:prstDash val="solid"/>
-                      <a:round/>
-                      <a:headEnd type="none" w="sm" len="sm"/>
-                      <a:tailEnd type="none" w="sm" len="sm"/>
-                    </a:lnR>
-                    <a:lnT w="9525" cap="flat" cmpd="sng">
-                      <a:solidFill>
-                        <a:schemeClr val="lt1"/>
-                      </a:solidFill>
-                      <a:prstDash val="solid"/>
-                      <a:round/>
-                      <a:headEnd type="none" w="sm" len="sm"/>
-                      <a:tailEnd type="none" w="sm" len="sm"/>
-                    </a:lnT>
-                    <a:lnB w="9525" cap="flat" cmpd="sng">
-                      <a:solidFill>
-                        <a:schemeClr val="lt1"/>
-                      </a:solidFill>
-                      <a:prstDash val="solid"/>
-                      <a:round/>
-                      <a:headEnd type="none" w="sm" len="sm"/>
-                      <a:tailEnd type="none" w="sm" len="sm"/>
-                    </a:lnB>
-                    <a:solidFill>
-                      <a:srgbClr val="BAF8FF"/>
-                    </a:solidFill>
-                  </a:tcPr>
-                </a:tc>
-                <a:extLst>
-                  <a:ext uri="{0D108BD9-81ED-4DB2-BD59-A6C34878D82A}">
-                    <a16:rowId xmlns:a16="http://schemas.microsoft.com/office/drawing/2014/main" val="10004"/>
-                  </a:ext>
-                </a:extLst>
-              </a:tr>
-              <a:tr h="123275">
-                <a:tc>
-                  <a:txBody>
-                    <a:bodyPr/>
-                    <a:lstStyle/>
-                    <a:p>
-                      <a:pPr marL="0" marR="0" lvl="0" indent="0" algn="l" rtl="0">
-                        <a:lnSpc>
-                          <a:spcPct val="100000"/>
-                        </a:lnSpc>
-                        <a:spcBef>
-                          <a:spcPts val="0"/>
-                        </a:spcBef>
-                        <a:spcAft>
-                          <a:spcPts val="0"/>
-                        </a:spcAft>
-                        <a:buNone/>
-                      </a:pPr>
-                      <a:r>
-                        <a:rPr lang="id" sz="1000" b="0" i="0" u="none" strike="noStrike" cap="none" dirty="0">
-                          <a:solidFill>
-                            <a:srgbClr val="000000"/>
-                          </a:solidFill>
-                          <a:latin typeface="Arial"/>
-                          <a:ea typeface="Arial"/>
-                          <a:cs typeface="Arial"/>
-                          <a:sym typeface="Arial"/>
-                        </a:rPr>
-                        <a:t>26 - 30</a:t>
-                      </a:r>
-                      <a:endParaRPr sz="1000" dirty="0"/>
-                    </a:p>
-                  </a:txBody>
-                  <a:tcPr marL="3800" marR="3800" marT="0" marB="0" anchor="ctr">
-                    <a:lnL w="9525" cap="flat" cmpd="sng">
-                      <a:solidFill>
-                        <a:schemeClr val="lt1"/>
-                      </a:solidFill>
-                      <a:prstDash val="solid"/>
-                      <a:round/>
-                      <a:headEnd type="none" w="sm" len="sm"/>
-                      <a:tailEnd type="none" w="sm" len="sm"/>
-                    </a:lnL>
-                    <a:lnR w="9525" cap="flat" cmpd="sng" algn="ctr">
-                      <a:solidFill>
-                        <a:schemeClr val="lt1"/>
-                      </a:solidFill>
-                      <a:prstDash val="solid"/>
-                      <a:round/>
-                      <a:headEnd type="none" w="sm" len="sm"/>
-                      <a:tailEnd type="none" w="sm" len="sm"/>
-                    </a:lnR>
-                    <a:lnT w="9525" cap="flat" cmpd="sng">
-                      <a:solidFill>
-                        <a:schemeClr val="lt1"/>
-                      </a:solidFill>
-                      <a:prstDash val="solid"/>
-                      <a:round/>
-                      <a:headEnd type="none" w="sm" len="sm"/>
-                      <a:tailEnd type="none" w="sm" len="sm"/>
-                    </a:lnT>
-                    <a:lnB w="9525" cap="flat" cmpd="sng">
-                      <a:solidFill>
-                        <a:schemeClr val="lt1"/>
-                      </a:solidFill>
-                      <a:prstDash val="solid"/>
-                      <a:round/>
-                      <a:headEnd type="none" w="sm" len="sm"/>
-                      <a:tailEnd type="none" w="sm" len="sm"/>
-                    </a:lnB>
-                    <a:solidFill>
-                      <a:srgbClr val="BAF8FF"/>
-                    </a:solidFill>
-                  </a:tcPr>
-                </a:tc>
-                <a:tc>
-                  <a:txBody>
-                    <a:bodyPr/>
-                    <a:lstStyle/>
-                    <a:p>
-                      <a:pPr algn="r" fontAlgn="b"/>
-                      <a:r>
-                        <a:rPr lang="en-US" sz="1100" b="0" i="0" u="none" strike="noStrike" dirty="0">
-                          <a:solidFill>
-                            <a:srgbClr val="000000"/>
-                          </a:solidFill>
-                          <a:effectLst/>
-                          <a:latin typeface="Calibri" panose="020F0502020204030204" pitchFamily="34" charset="0"/>
-                        </a:rPr>
-                        <a:t>{count_26_30}</a:t>
-                      </a:r>
-                    </a:p>
-                  </a:txBody>
-                  <a:tcPr marL="7620" marR="7620" marT="0" marB="0" anchor="b">
-                    <a:lnL w="9525" cap="flat" cmpd="sng">
-                      <a:solidFill>
-                        <a:schemeClr val="lt1"/>
-                      </a:solidFill>
-                      <a:prstDash val="solid"/>
-                      <a:round/>
-                      <a:headEnd type="none" w="sm" len="sm"/>
-                      <a:tailEnd type="none" w="sm" len="sm"/>
-                    </a:lnL>
-                    <a:lnR w="9525" cap="flat" cmpd="sng">
-                      <a:solidFill>
-                        <a:schemeClr val="lt1"/>
-                      </a:solidFill>
-                      <a:prstDash val="solid"/>
-                      <a:round/>
-                      <a:headEnd type="none" w="sm" len="sm"/>
-                      <a:tailEnd type="none" w="sm" len="sm"/>
-                    </a:lnR>
-                    <a:lnT w="9525" cap="flat" cmpd="sng">
-                      <a:solidFill>
-                        <a:schemeClr val="lt1"/>
-                      </a:solidFill>
-                      <a:prstDash val="solid"/>
-                      <a:round/>
-                      <a:headEnd type="none" w="sm" len="sm"/>
-                      <a:tailEnd type="none" w="sm" len="sm"/>
-                    </a:lnT>
-                    <a:lnB w="9525" cap="flat" cmpd="sng">
-                      <a:solidFill>
-                        <a:schemeClr val="lt1"/>
-                      </a:solidFill>
-                      <a:prstDash val="solid"/>
-                      <a:round/>
-                      <a:headEnd type="none" w="sm" len="sm"/>
-                      <a:tailEnd type="none" w="sm" len="sm"/>
-                    </a:lnB>
-                    <a:solidFill>
-                      <a:srgbClr val="BAF8FF"/>
-                    </a:solidFill>
-                  </a:tcPr>
-                </a:tc>
-                <a:extLst>
-                  <a:ext uri="{0D108BD9-81ED-4DB2-BD59-A6C34878D82A}">
-                    <a16:rowId xmlns:a16="http://schemas.microsoft.com/office/drawing/2014/main" val="10005"/>
-                  </a:ext>
-                </a:extLst>
-              </a:tr>
-              <a:tr h="123275">
-                <a:tc>
-                  <a:txBody>
-                    <a:bodyPr/>
-                    <a:lstStyle/>
-                    <a:p>
-                      <a:pPr marL="0" marR="0" lvl="0" indent="0" algn="l" rtl="0">
-                        <a:lnSpc>
-                          <a:spcPct val="100000"/>
-                        </a:lnSpc>
-                        <a:spcBef>
-                          <a:spcPts val="0"/>
-                        </a:spcBef>
-                        <a:spcAft>
-                          <a:spcPts val="0"/>
-                        </a:spcAft>
-                        <a:buNone/>
-                      </a:pPr>
-                      <a:r>
-                        <a:rPr lang="id" sz="1000" b="0" i="0" u="none" strike="noStrike" cap="none" dirty="0">
-                          <a:solidFill>
-                            <a:srgbClr val="000000"/>
-                          </a:solidFill>
-                          <a:latin typeface="Arial"/>
-                          <a:ea typeface="Arial"/>
-                          <a:cs typeface="Arial"/>
-                          <a:sym typeface="Arial"/>
-                        </a:rPr>
-                        <a:t>&gt; 30</a:t>
-                      </a:r>
-                      <a:endParaRPr sz="1000" dirty="0"/>
-                    </a:p>
-                  </a:txBody>
-                  <a:tcPr marL="3800" marR="3800" marT="0" marB="0" anchor="ctr">
-                    <a:lnL w="9525" cap="flat" cmpd="sng">
-                      <a:solidFill>
-                        <a:schemeClr val="lt1"/>
-                      </a:solidFill>
-                      <a:prstDash val="solid"/>
-                      <a:round/>
-                      <a:headEnd type="none" w="sm" len="sm"/>
-                      <a:tailEnd type="none" w="sm" len="sm"/>
-                    </a:lnL>
-                    <a:lnR w="9525" cap="flat" cmpd="sng" algn="ctr">
-                      <a:solidFill>
-                        <a:schemeClr val="lt1"/>
-                      </a:solidFill>
-                      <a:prstDash val="solid"/>
-                      <a:round/>
-                      <a:headEnd type="none" w="sm" len="sm"/>
-                      <a:tailEnd type="none" w="sm" len="sm"/>
-                    </a:lnR>
-                    <a:lnT w="9525" cap="flat" cmpd="sng">
-                      <a:solidFill>
-                        <a:schemeClr val="lt1"/>
-                      </a:solidFill>
-                      <a:prstDash val="solid"/>
-                      <a:round/>
-                      <a:headEnd type="none" w="sm" len="sm"/>
-                      <a:tailEnd type="none" w="sm" len="sm"/>
-                    </a:lnT>
-                    <a:lnB w="9525" cap="flat" cmpd="sng">
-                      <a:solidFill>
-                        <a:schemeClr val="lt1"/>
-                      </a:solidFill>
-                      <a:prstDash val="solid"/>
-                      <a:round/>
-                      <a:headEnd type="none" w="sm" len="sm"/>
-                      <a:tailEnd type="none" w="sm" len="sm"/>
-                    </a:lnB>
-                    <a:solidFill>
-                      <a:srgbClr val="BAF8FF"/>
-                    </a:solidFill>
-                  </a:tcPr>
-                </a:tc>
-                <a:tc>
-                  <a:txBody>
-                    <a:bodyPr/>
-                    <a:lstStyle/>
-                    <a:p>
-                      <a:pPr algn="r" fontAlgn="b"/>
-                      <a:r>
-                        <a:rPr lang="en-US" sz="1100" b="0" i="0" u="none" strike="noStrike" dirty="0">
-                          <a:solidFill>
-                            <a:srgbClr val="000000"/>
-                          </a:solidFill>
-                          <a:effectLst/>
-                          <a:latin typeface="Calibri" panose="020F0502020204030204" pitchFamily="34" charset="0"/>
-                        </a:rPr>
-                        <a:t>{count_30}</a:t>
-                      </a:r>
-                    </a:p>
-                  </a:txBody>
-                  <a:tcPr marL="7620" marR="7620" marT="0" marB="0" anchor="b">
-                    <a:lnL w="9525" cap="flat" cmpd="sng">
-                      <a:solidFill>
-                        <a:schemeClr val="lt1"/>
-                      </a:solidFill>
-                      <a:prstDash val="solid"/>
-                      <a:round/>
-                      <a:headEnd type="none" w="sm" len="sm"/>
-                      <a:tailEnd type="none" w="sm" len="sm"/>
-                    </a:lnL>
-                    <a:lnR w="9525" cap="flat" cmpd="sng">
-                      <a:solidFill>
-                        <a:schemeClr val="lt1"/>
-                      </a:solidFill>
-                      <a:prstDash val="solid"/>
-                      <a:round/>
-                      <a:headEnd type="none" w="sm" len="sm"/>
-                      <a:tailEnd type="none" w="sm" len="sm"/>
-                    </a:lnR>
-                    <a:lnT w="9525" cap="flat" cmpd="sng">
-                      <a:solidFill>
-                        <a:schemeClr val="lt1"/>
-                      </a:solidFill>
-                      <a:prstDash val="solid"/>
-                      <a:round/>
-                      <a:headEnd type="none" w="sm" len="sm"/>
-                      <a:tailEnd type="none" w="sm" len="sm"/>
-                    </a:lnT>
-                    <a:lnB w="9525" cap="flat" cmpd="sng">
-                      <a:solidFill>
-                        <a:schemeClr val="lt1"/>
-                      </a:solidFill>
-                      <a:prstDash val="solid"/>
-                      <a:round/>
-                      <a:headEnd type="none" w="sm" len="sm"/>
-                      <a:tailEnd type="none" w="sm" len="sm"/>
-                    </a:lnB>
-                    <a:solidFill>
-                      <a:srgbClr val="BAF8FF"/>
-                    </a:solidFill>
-                  </a:tcPr>
-                </a:tc>
-                <a:extLst>
-                  <a:ext uri="{0D108BD9-81ED-4DB2-BD59-A6C34878D82A}">
-                    <a16:rowId xmlns:a16="http://schemas.microsoft.com/office/drawing/2014/main" val="10006"/>
-                  </a:ext>
-                </a:extLst>
-              </a:tr>
-            </a:tbl>
-          </a:graphicData>
-        </a:graphic>
-      </p:graphicFrame>
       <p:sp>
         <p:nvSpPr>
           <p:cNvPr id="769" name="Google Shape;769;p75"/>
@@ -20037,483 +18983,6 @@
           </a:p>
         </p:txBody>
       </p:sp>
-      <p:graphicFrame>
-        <p:nvGraphicFramePr>
-          <p:cNvPr id="776" name="table_3"/>
-          <p:cNvGraphicFramePr/>
-          <p:nvPr>
-            <p:extLst>
-              <p:ext uri="{D42A27DB-BD31-4B8C-83A1-F6EECF244321}">
-                <p14:modId xmlns:p14="http://schemas.microsoft.com/office/powerpoint/2010/main" val="3090801961"/>
-              </p:ext>
-            </p:extLst>
-          </p:nvPr>
-        </p:nvGraphicFramePr>
-        <p:xfrm>
-          <a:off x="3010252" y="3211212"/>
-          <a:ext cx="1306491" cy="3179064"/>
-        </p:xfrm>
-        <a:graphic>
-          <a:graphicData uri="http://schemas.openxmlformats.org/drawingml/2006/table">
-            <a:tbl>
-              <a:tblPr>
-                <a:noFill/>
-                <a:tableStyleId>{43F93C65-BEC1-43AD-96CD-C93F1471F904}</a:tableStyleId>
-              </a:tblPr>
-              <a:tblGrid>
-                <a:gridCol w="669119">
-                  <a:extLst>
-                    <a:ext uri="{9D8B030D-6E8A-4147-A177-3AD203B41FA5}">
-                      <a16:colId xmlns:a16="http://schemas.microsoft.com/office/drawing/2014/main" val="20000"/>
-                    </a:ext>
-                  </a:extLst>
-                </a:gridCol>
-                <a:gridCol w="637372">
-                  <a:extLst>
-                    <a:ext uri="{9D8B030D-6E8A-4147-A177-3AD203B41FA5}">
-                      <a16:colId xmlns:a16="http://schemas.microsoft.com/office/drawing/2014/main" val="20001"/>
-                    </a:ext>
-                  </a:extLst>
-                </a:gridCol>
-              </a:tblGrid>
-              <a:tr h="192608">
-                <a:tc>
-                  <a:txBody>
-                    <a:bodyPr/>
-                    <a:lstStyle/>
-                    <a:p>
-                      <a:pPr marL="0" marR="0" lvl="0" indent="0" algn="l" rtl="0">
-                        <a:lnSpc>
-                          <a:spcPct val="100000"/>
-                        </a:lnSpc>
-                        <a:spcBef>
-                          <a:spcPts val="0"/>
-                        </a:spcBef>
-                        <a:spcAft>
-                          <a:spcPts val="0"/>
-                        </a:spcAft>
-                        <a:buNone/>
-                      </a:pPr>
-                      <a:r>
-                        <a:rPr lang="en-US" sz="1100" dirty="0"/>
-                        <a:t>18 - 20</a:t>
-                      </a:r>
-                      <a:endParaRPr sz="1100" dirty="0"/>
-                    </a:p>
-                  </a:txBody>
-                  <a:tcPr marL="3800" marR="3800" marT="0" marB="0" anchor="ctr">
-                    <a:solidFill>
-                      <a:srgbClr val="BAF8FF"/>
-                    </a:solidFill>
-                  </a:tcPr>
-                </a:tc>
-                <a:tc>
-                  <a:txBody>
-                    <a:bodyPr/>
-                    <a:lstStyle/>
-                    <a:p>
-                      <a:pPr marL="0" lvl="0" indent="0" algn="r" rtl="0">
-                        <a:lnSpc>
-                          <a:spcPct val="115000"/>
-                        </a:lnSpc>
-                        <a:spcBef>
-                          <a:spcPts val="0"/>
-                        </a:spcBef>
-                        <a:spcAft>
-                          <a:spcPts val="0"/>
-                        </a:spcAft>
-                        <a:buNone/>
-                      </a:pPr>
-                      <a:r>
-                        <a:rPr lang="en-US" sz="1100" dirty="0"/>
-                        <a:t>{count_18_20}</a:t>
-                      </a:r>
-                      <a:endParaRPr sz="1100" dirty="0"/>
-                    </a:p>
-                  </a:txBody>
-                  <a:tcPr marL="91425" marR="91425" marT="0" marB="0">
-                    <a:solidFill>
-                      <a:srgbClr val="BAF8FF"/>
-                    </a:solidFill>
-                  </a:tcPr>
-                </a:tc>
-                <a:extLst>
-                  <a:ext uri="{0D108BD9-81ED-4DB2-BD59-A6C34878D82A}">
-                    <a16:rowId xmlns:a16="http://schemas.microsoft.com/office/drawing/2014/main" val="1421157024"/>
-                  </a:ext>
-                </a:extLst>
-              </a:tr>
-              <a:tr h="192608">
-                <a:tc>
-                  <a:txBody>
-                    <a:bodyPr/>
-                    <a:lstStyle/>
-                    <a:p>
-                      <a:pPr marL="0" marR="0" lvl="0" indent="0" algn="l" rtl="0">
-                        <a:lnSpc>
-                          <a:spcPct val="100000"/>
-                        </a:lnSpc>
-                        <a:spcBef>
-                          <a:spcPts val="0"/>
-                        </a:spcBef>
-                        <a:spcAft>
-                          <a:spcPts val="0"/>
-                        </a:spcAft>
-                        <a:buNone/>
-                      </a:pPr>
-                      <a:r>
-                        <a:rPr lang="id" sz="1100" b="0" i="0" u="none" strike="noStrike" cap="none" dirty="0">
-                          <a:solidFill>
-                            <a:srgbClr val="000000"/>
-                          </a:solidFill>
-                          <a:latin typeface="Arial"/>
-                          <a:ea typeface="Arial"/>
-                          <a:cs typeface="Arial"/>
-                          <a:sym typeface="Arial"/>
-                        </a:rPr>
-                        <a:t>21 - 30</a:t>
-                      </a:r>
-                      <a:endParaRPr sz="1200" dirty="0"/>
-                    </a:p>
-                  </a:txBody>
-                  <a:tcPr marL="3800" marR="3800" marT="0" marB="0" anchor="ctr">
-                    <a:solidFill>
-                      <a:srgbClr val="BAF8FF"/>
-                    </a:solidFill>
-                  </a:tcPr>
-                </a:tc>
-                <a:tc>
-                  <a:txBody>
-                    <a:bodyPr/>
-                    <a:lstStyle/>
-                    <a:p>
-                      <a:pPr marL="0" lvl="0" indent="0" algn="r" rtl="0">
-                        <a:lnSpc>
-                          <a:spcPct val="115000"/>
-                        </a:lnSpc>
-                        <a:spcBef>
-                          <a:spcPts val="0"/>
-                        </a:spcBef>
-                        <a:spcAft>
-                          <a:spcPts val="0"/>
-                        </a:spcAft>
-                        <a:buNone/>
-                      </a:pPr>
-                      <a:r>
-                        <a:rPr lang="en-US" sz="1100" dirty="0"/>
-                        <a:t>{count_21_30}</a:t>
-                      </a:r>
-                      <a:endParaRPr sz="1100" dirty="0"/>
-                    </a:p>
-                  </a:txBody>
-                  <a:tcPr marL="91425" marR="91425" marT="0" marB="0">
-                    <a:solidFill>
-                      <a:srgbClr val="BAF8FF"/>
-                    </a:solidFill>
-                  </a:tcPr>
-                </a:tc>
-                <a:extLst>
-                  <a:ext uri="{0D108BD9-81ED-4DB2-BD59-A6C34878D82A}">
-                    <a16:rowId xmlns:a16="http://schemas.microsoft.com/office/drawing/2014/main" val="10000"/>
-                  </a:ext>
-                </a:extLst>
-              </a:tr>
-              <a:tr h="192608">
-                <a:tc>
-                  <a:txBody>
-                    <a:bodyPr/>
-                    <a:lstStyle/>
-                    <a:p>
-                      <a:pPr marL="0" marR="0" lvl="0" indent="0" algn="l" rtl="0">
-                        <a:lnSpc>
-                          <a:spcPct val="100000"/>
-                        </a:lnSpc>
-                        <a:spcBef>
-                          <a:spcPts val="0"/>
-                        </a:spcBef>
-                        <a:spcAft>
-                          <a:spcPts val="0"/>
-                        </a:spcAft>
-                        <a:buNone/>
-                      </a:pPr>
-                      <a:r>
-                        <a:rPr lang="id" sz="1100" b="0" i="0" u="none" strike="noStrike" cap="none" dirty="0">
-                          <a:solidFill>
-                            <a:srgbClr val="000000"/>
-                          </a:solidFill>
-                          <a:latin typeface="Arial"/>
-                          <a:ea typeface="Arial"/>
-                          <a:cs typeface="Arial"/>
-                          <a:sym typeface="Arial"/>
-                        </a:rPr>
-                        <a:t>31 - 40</a:t>
-                      </a:r>
-                      <a:endParaRPr sz="1200" dirty="0"/>
-                    </a:p>
-                  </a:txBody>
-                  <a:tcPr marL="3800" marR="3800" marT="0" marB="0" anchor="ctr">
-                    <a:solidFill>
-                      <a:srgbClr val="BAF8FF"/>
-                    </a:solidFill>
-                  </a:tcPr>
-                </a:tc>
-                <a:tc>
-                  <a:txBody>
-                    <a:bodyPr/>
-                    <a:lstStyle/>
-                    <a:p>
-                      <a:pPr marL="0" lvl="0" indent="0" algn="r" rtl="0">
-                        <a:lnSpc>
-                          <a:spcPct val="115000"/>
-                        </a:lnSpc>
-                        <a:spcBef>
-                          <a:spcPts val="0"/>
-                        </a:spcBef>
-                        <a:spcAft>
-                          <a:spcPts val="0"/>
-                        </a:spcAft>
-                        <a:buNone/>
-                      </a:pPr>
-                      <a:r>
-                        <a:rPr lang="en-US" sz="1100" dirty="0"/>
-                        <a:t>{count_31_40}</a:t>
-                      </a:r>
-                      <a:endParaRPr sz="1100" dirty="0"/>
-                    </a:p>
-                  </a:txBody>
-                  <a:tcPr marL="91425" marR="91425" marT="0" marB="0">
-                    <a:solidFill>
-                      <a:srgbClr val="BAF8FF"/>
-                    </a:solidFill>
-                  </a:tcPr>
-                </a:tc>
-                <a:extLst>
-                  <a:ext uri="{0D108BD9-81ED-4DB2-BD59-A6C34878D82A}">
-                    <a16:rowId xmlns:a16="http://schemas.microsoft.com/office/drawing/2014/main" val="10001"/>
-                  </a:ext>
-                </a:extLst>
-              </a:tr>
-              <a:tr h="192608">
-                <a:tc>
-                  <a:txBody>
-                    <a:bodyPr/>
-                    <a:lstStyle/>
-                    <a:p>
-                      <a:pPr marL="0" marR="0" lvl="0" indent="0" algn="l" rtl="0">
-                        <a:lnSpc>
-                          <a:spcPct val="100000"/>
-                        </a:lnSpc>
-                        <a:spcBef>
-                          <a:spcPts val="0"/>
-                        </a:spcBef>
-                        <a:spcAft>
-                          <a:spcPts val="0"/>
-                        </a:spcAft>
-                        <a:buNone/>
-                      </a:pPr>
-                      <a:r>
-                        <a:rPr lang="id" sz="1100" b="0" i="0" u="none" strike="noStrike" cap="none" dirty="0">
-                          <a:solidFill>
-                            <a:srgbClr val="000000"/>
-                          </a:solidFill>
-                          <a:latin typeface="Arial"/>
-                          <a:ea typeface="Arial"/>
-                          <a:cs typeface="Arial"/>
-                          <a:sym typeface="Arial"/>
-                        </a:rPr>
-                        <a:t>41 - 50</a:t>
-                      </a:r>
-                      <a:endParaRPr sz="1200" dirty="0"/>
-                    </a:p>
-                  </a:txBody>
-                  <a:tcPr marL="3800" marR="3800" marT="0" marB="0" anchor="ctr">
-                    <a:solidFill>
-                      <a:srgbClr val="BAF8FF"/>
-                    </a:solidFill>
-                  </a:tcPr>
-                </a:tc>
-                <a:tc>
-                  <a:txBody>
-                    <a:bodyPr/>
-                    <a:lstStyle/>
-                    <a:p>
-                      <a:pPr marL="0" lvl="0" indent="0" algn="r" rtl="0">
-                        <a:lnSpc>
-                          <a:spcPct val="115000"/>
-                        </a:lnSpc>
-                        <a:spcBef>
-                          <a:spcPts val="0"/>
-                        </a:spcBef>
-                        <a:spcAft>
-                          <a:spcPts val="0"/>
-                        </a:spcAft>
-                        <a:buNone/>
-                      </a:pPr>
-                      <a:r>
-                        <a:rPr lang="en-US" sz="1100" dirty="0"/>
-                        <a:t>{count_41_50}</a:t>
-                      </a:r>
-                      <a:endParaRPr sz="1100" dirty="0"/>
-                    </a:p>
-                  </a:txBody>
-                  <a:tcPr marL="91425" marR="91425" marT="0" marB="0">
-                    <a:solidFill>
-                      <a:srgbClr val="BAF8FF"/>
-                    </a:solidFill>
-                  </a:tcPr>
-                </a:tc>
-                <a:extLst>
-                  <a:ext uri="{0D108BD9-81ED-4DB2-BD59-A6C34878D82A}">
-                    <a16:rowId xmlns:a16="http://schemas.microsoft.com/office/drawing/2014/main" val="10002"/>
-                  </a:ext>
-                </a:extLst>
-              </a:tr>
-              <a:tr h="192608">
-                <a:tc>
-                  <a:txBody>
-                    <a:bodyPr/>
-                    <a:lstStyle/>
-                    <a:p>
-                      <a:pPr marL="0" marR="0" lvl="0" indent="0" algn="l" rtl="0">
-                        <a:lnSpc>
-                          <a:spcPct val="100000"/>
-                        </a:lnSpc>
-                        <a:spcBef>
-                          <a:spcPts val="0"/>
-                        </a:spcBef>
-                        <a:spcAft>
-                          <a:spcPts val="0"/>
-                        </a:spcAft>
-                        <a:buNone/>
-                      </a:pPr>
-                      <a:r>
-                        <a:rPr lang="id" sz="1100" b="0" i="0" u="none" strike="noStrike" cap="none" dirty="0">
-                          <a:solidFill>
-                            <a:srgbClr val="000000"/>
-                          </a:solidFill>
-                          <a:latin typeface="Arial"/>
-                          <a:ea typeface="Arial"/>
-                          <a:cs typeface="Arial"/>
-                          <a:sym typeface="Arial"/>
-                        </a:rPr>
-                        <a:t>51 - 60</a:t>
-                      </a:r>
-                      <a:endParaRPr sz="1200" dirty="0"/>
-                    </a:p>
-                  </a:txBody>
-                  <a:tcPr marL="3800" marR="3800" marT="0" marB="0" anchor="ctr">
-                    <a:solidFill>
-                      <a:srgbClr val="BAF8FF"/>
-                    </a:solidFill>
-                  </a:tcPr>
-                </a:tc>
-                <a:tc>
-                  <a:txBody>
-                    <a:bodyPr/>
-                    <a:lstStyle/>
-                    <a:p>
-                      <a:pPr marL="0" lvl="0" indent="0" algn="r" rtl="0">
-                        <a:lnSpc>
-                          <a:spcPct val="115000"/>
-                        </a:lnSpc>
-                        <a:spcBef>
-                          <a:spcPts val="0"/>
-                        </a:spcBef>
-                        <a:spcAft>
-                          <a:spcPts val="0"/>
-                        </a:spcAft>
-                        <a:buNone/>
-                      </a:pPr>
-                      <a:r>
-                        <a:rPr lang="en-US" sz="1100" dirty="0"/>
-                        <a:t>{count_51_60}</a:t>
-                      </a:r>
-                      <a:endParaRPr sz="1100" dirty="0"/>
-                    </a:p>
-                  </a:txBody>
-                  <a:tcPr marL="91425" marR="91425" marT="0" marB="0">
-                    <a:solidFill>
-                      <a:srgbClr val="BAF8FF"/>
-                    </a:solidFill>
-                  </a:tcPr>
-                </a:tc>
-                <a:extLst>
-                  <a:ext uri="{0D108BD9-81ED-4DB2-BD59-A6C34878D82A}">
-                    <a16:rowId xmlns:a16="http://schemas.microsoft.com/office/drawing/2014/main" val="10003"/>
-                  </a:ext>
-                </a:extLst>
-              </a:tr>
-              <a:tr h="192608">
-                <a:tc>
-                  <a:txBody>
-                    <a:bodyPr/>
-                    <a:lstStyle/>
-                    <a:p>
-                      <a:pPr marL="0" marR="0" lvl="0" indent="0" algn="l" rtl="0">
-                        <a:lnSpc>
-                          <a:spcPct val="100000"/>
-                        </a:lnSpc>
-                        <a:spcBef>
-                          <a:spcPts val="0"/>
-                        </a:spcBef>
-                        <a:spcAft>
-                          <a:spcPts val="0"/>
-                        </a:spcAft>
-                        <a:buNone/>
-                      </a:pPr>
-                      <a:r>
-                        <a:rPr lang="en-US" sz="1200" dirty="0"/>
-                        <a:t>&gt; 60</a:t>
-                      </a:r>
-                      <a:endParaRPr sz="1200" dirty="0"/>
-                    </a:p>
-                  </a:txBody>
-                  <a:tcPr marL="3800" marR="3800" marT="0" marB="0" anchor="ctr">
-                    <a:solidFill>
-                      <a:srgbClr val="BAF8FF"/>
-                    </a:solidFill>
-                  </a:tcPr>
-                </a:tc>
-                <a:tc>
-                  <a:txBody>
-                    <a:bodyPr/>
-                    <a:lstStyle/>
-                    <a:p>
-                      <a:pPr marL="0" lvl="0" indent="0" algn="r" rtl="0">
-                        <a:lnSpc>
-                          <a:spcPct val="115000"/>
-                        </a:lnSpc>
-                        <a:spcBef>
-                          <a:spcPts val="0"/>
-                        </a:spcBef>
-                        <a:spcAft>
-                          <a:spcPts val="0"/>
-                        </a:spcAft>
-                        <a:buNone/>
-                      </a:pPr>
-                      <a:r>
-                        <a:rPr lang="en-US" sz="1100" dirty="0"/>
-                        <a:t>{count_60}</a:t>
-                      </a:r>
-                      <a:endParaRPr sz="1100" dirty="0"/>
-                    </a:p>
-                  </a:txBody>
-                  <a:tcPr marL="91425" marR="91425" marT="0" marB="0">
-                    <a:solidFill>
-                      <a:srgbClr val="BAF8FF"/>
-                    </a:solidFill>
-                  </a:tcPr>
-                </a:tc>
-                <a:extLst>
-                  <a:ext uri="{0D108BD9-81ED-4DB2-BD59-A6C34878D82A}">
-                    <a16:rowId xmlns:a16="http://schemas.microsoft.com/office/drawing/2014/main" val="2570087131"/>
-                  </a:ext>
-                </a:extLst>
-              </a:tr>
-            </a:tbl>
-          </a:graphicData>
-        </a:graphic>
-      </p:graphicFrame>
       <p:sp>
         <p:nvSpPr>
           <p:cNvPr id="777" name="Google Shape;777;p75"/>
@@ -21010,1466 +19479,6 @@
           </p:txBody>
         </p:sp>
       </p:grpSp>
-      <p:graphicFrame>
-        <p:nvGraphicFramePr>
-          <p:cNvPr id="791" name="table_5"/>
-          <p:cNvGraphicFramePr/>
-          <p:nvPr>
-            <p:extLst>
-              <p:ext uri="{D42A27DB-BD31-4B8C-83A1-F6EECF244321}">
-                <p14:modId xmlns:p14="http://schemas.microsoft.com/office/powerpoint/2010/main" val="3889782096"/>
-              </p:ext>
-            </p:extLst>
-          </p:nvPr>
-        </p:nvGraphicFramePr>
-        <p:xfrm>
-          <a:off x="5022366" y="3598028"/>
-          <a:ext cx="1100850" cy="1760160"/>
-        </p:xfrm>
-        <a:graphic>
-          <a:graphicData uri="http://schemas.openxmlformats.org/drawingml/2006/table">
-            <a:tbl>
-              <a:tblPr>
-                <a:noFill/>
-                <a:tableStyleId>{43F93C65-BEC1-43AD-96CD-C93F1471F904}</a:tableStyleId>
-              </a:tblPr>
-              <a:tblGrid>
-                <a:gridCol w="865675">
-                  <a:extLst>
-                    <a:ext uri="{9D8B030D-6E8A-4147-A177-3AD203B41FA5}">
-                      <a16:colId xmlns:a16="http://schemas.microsoft.com/office/drawing/2014/main" val="20000"/>
-                    </a:ext>
-                  </a:extLst>
-                </a:gridCol>
-                <a:gridCol w="235175">
-                  <a:extLst>
-                    <a:ext uri="{9D8B030D-6E8A-4147-A177-3AD203B41FA5}">
-                      <a16:colId xmlns:a16="http://schemas.microsoft.com/office/drawing/2014/main" val="20001"/>
-                    </a:ext>
-                  </a:extLst>
-                </a:gridCol>
-              </a:tblGrid>
-              <a:tr h="116675">
-                <a:tc>
-                  <a:txBody>
-                    <a:bodyPr/>
-                    <a:lstStyle/>
-                    <a:p>
-                      <a:pPr marL="0" marR="0" lvl="0" indent="0" algn="l" rtl="0">
-                        <a:lnSpc>
-                          <a:spcPct val="100000"/>
-                        </a:lnSpc>
-                        <a:spcBef>
-                          <a:spcPts val="0"/>
-                        </a:spcBef>
-                        <a:spcAft>
-                          <a:spcPts val="0"/>
-                        </a:spcAft>
-                        <a:buNone/>
-                      </a:pPr>
-                      <a:r>
-                        <a:rPr lang="en-US" sz="600" u="none" strike="noStrike" cap="none" dirty="0">
-                          <a:latin typeface="Arial"/>
-                          <a:ea typeface="Arial"/>
-                          <a:cs typeface="Arial"/>
-                          <a:sym typeface="Arial"/>
-                        </a:rPr>
-                        <a:t>PNS JPT Utama</a:t>
-                      </a:r>
-                      <a:endParaRPr sz="600" b="0" i="0" u="none" strike="noStrike" cap="none" dirty="0">
-                        <a:solidFill>
-                          <a:srgbClr val="000000"/>
-                        </a:solidFill>
-                        <a:latin typeface="Arial"/>
-                        <a:ea typeface="Arial"/>
-                        <a:cs typeface="Arial"/>
-                        <a:sym typeface="Arial"/>
-                      </a:endParaRPr>
-                    </a:p>
-                  </a:txBody>
-                  <a:tcPr marL="3800" marR="3800" marT="3800" marB="0" anchor="b">
-                    <a:solidFill>
-                      <a:srgbClr val="FDEADA"/>
-                    </a:solidFill>
-                  </a:tcPr>
-                </a:tc>
-                <a:tc>
-                  <a:txBody>
-                    <a:bodyPr/>
-                    <a:lstStyle/>
-                    <a:p>
-                      <a:pPr marL="0" marR="0" lvl="0" indent="0" algn="r" rtl="0">
-                        <a:lnSpc>
-                          <a:spcPct val="100000"/>
-                        </a:lnSpc>
-                        <a:spcBef>
-                          <a:spcPts val="0"/>
-                        </a:spcBef>
-                        <a:spcAft>
-                          <a:spcPts val="0"/>
-                        </a:spcAft>
-                        <a:buNone/>
-                      </a:pPr>
-                      <a:r>
-                        <a:rPr lang="en-US" sz="600" u="none" strike="noStrike" cap="none" dirty="0">
-                          <a:latin typeface="Arial"/>
-                          <a:ea typeface="Arial"/>
-                          <a:cs typeface="Arial"/>
-                          <a:sym typeface="Arial"/>
-                        </a:rPr>
-                        <a:t>{</a:t>
-                      </a:r>
-                      <a:r>
-                        <a:rPr lang="en-US" sz="600" u="none" strike="noStrike" cap="none" dirty="0" err="1">
-                          <a:latin typeface="Arial"/>
-                          <a:ea typeface="Arial"/>
-                          <a:cs typeface="Arial"/>
-                          <a:sym typeface="Arial"/>
-                        </a:rPr>
-                        <a:t>count_utama</a:t>
-                      </a:r>
-                      <a:r>
-                        <a:rPr lang="en-US" sz="600" u="none" strike="noStrike" cap="none" dirty="0">
-                          <a:latin typeface="Arial"/>
-                          <a:ea typeface="Arial"/>
-                          <a:cs typeface="Arial"/>
-                          <a:sym typeface="Arial"/>
-                        </a:rPr>
-                        <a:t>}</a:t>
-                      </a:r>
-                      <a:endParaRPr sz="600" b="0" i="0" u="none" strike="noStrike" cap="none" dirty="0">
-                        <a:solidFill>
-                          <a:srgbClr val="000000"/>
-                        </a:solidFill>
-                        <a:latin typeface="Arial"/>
-                        <a:ea typeface="Arial"/>
-                        <a:cs typeface="Arial"/>
-                        <a:sym typeface="Arial"/>
-                      </a:endParaRPr>
-                    </a:p>
-                  </a:txBody>
-                  <a:tcPr marL="3800" marR="3800" marT="3800" marB="0" anchor="b">
-                    <a:solidFill>
-                      <a:srgbClr val="FDEADA"/>
-                    </a:solidFill>
-                  </a:tcPr>
-                </a:tc>
-                <a:extLst>
-                  <a:ext uri="{0D108BD9-81ED-4DB2-BD59-A6C34878D82A}">
-                    <a16:rowId xmlns:a16="http://schemas.microsoft.com/office/drawing/2014/main" val="10000"/>
-                  </a:ext>
-                </a:extLst>
-              </a:tr>
-              <a:tr h="116675">
-                <a:tc>
-                  <a:txBody>
-                    <a:bodyPr/>
-                    <a:lstStyle/>
-                    <a:p>
-                      <a:pPr marL="0" marR="0" lvl="0" indent="0" algn="l" rtl="0">
-                        <a:lnSpc>
-                          <a:spcPct val="100000"/>
-                        </a:lnSpc>
-                        <a:spcBef>
-                          <a:spcPts val="0"/>
-                        </a:spcBef>
-                        <a:spcAft>
-                          <a:spcPts val="0"/>
-                        </a:spcAft>
-                        <a:buNone/>
-                      </a:pPr>
-                      <a:r>
-                        <a:rPr lang="id" sz="600" u="none" strike="noStrike" cap="none" dirty="0">
-                          <a:latin typeface="Arial"/>
-                          <a:ea typeface="Arial"/>
-                          <a:cs typeface="Arial"/>
-                          <a:sym typeface="Arial"/>
-                        </a:rPr>
-                        <a:t>PNS JPT </a:t>
-                      </a:r>
-                      <a:r>
-                        <a:rPr lang="en-US" sz="600" u="none" strike="noStrike" cap="none" dirty="0">
-                          <a:latin typeface="Arial"/>
-                          <a:ea typeface="Arial"/>
-                          <a:cs typeface="Arial"/>
-                          <a:sym typeface="Arial"/>
-                        </a:rPr>
-                        <a:t>Madya</a:t>
-                      </a:r>
-                      <a:endParaRPr sz="600" b="0" i="0" u="none" strike="noStrike" cap="none" dirty="0">
-                        <a:solidFill>
-                          <a:srgbClr val="000000"/>
-                        </a:solidFill>
-                        <a:latin typeface="Arial"/>
-                        <a:ea typeface="Arial"/>
-                        <a:cs typeface="Arial"/>
-                        <a:sym typeface="Arial"/>
-                      </a:endParaRPr>
-                    </a:p>
-                  </a:txBody>
-                  <a:tcPr marL="3800" marR="3800" marT="3800" marB="0" anchor="b">
-                    <a:solidFill>
-                      <a:srgbClr val="FDEADA"/>
-                    </a:solidFill>
-                  </a:tcPr>
-                </a:tc>
-                <a:tc>
-                  <a:txBody>
-                    <a:bodyPr/>
-                    <a:lstStyle/>
-                    <a:p>
-                      <a:pPr marL="0" marR="0" lvl="0" indent="0" algn="r" rtl="0">
-                        <a:lnSpc>
-                          <a:spcPct val="100000"/>
-                        </a:lnSpc>
-                        <a:spcBef>
-                          <a:spcPts val="0"/>
-                        </a:spcBef>
-                        <a:spcAft>
-                          <a:spcPts val="0"/>
-                        </a:spcAft>
-                        <a:buNone/>
-                      </a:pPr>
-                      <a:r>
-                        <a:rPr lang="en-US" sz="600" u="none" strike="noStrike" cap="none" dirty="0">
-                          <a:latin typeface="Arial"/>
-                          <a:ea typeface="Arial"/>
-                          <a:cs typeface="Arial"/>
-                          <a:sym typeface="Arial"/>
-                        </a:rPr>
-                        <a:t>{</a:t>
-                      </a:r>
-                      <a:r>
-                        <a:rPr lang="en-US" sz="600" u="none" strike="noStrike" cap="none" dirty="0" err="1">
-                          <a:latin typeface="Arial"/>
-                          <a:ea typeface="Arial"/>
-                          <a:cs typeface="Arial"/>
-                          <a:sym typeface="Arial"/>
-                        </a:rPr>
-                        <a:t>count_madya</a:t>
-                      </a:r>
-                      <a:r>
-                        <a:rPr lang="en-US" sz="600" u="none" strike="noStrike" cap="none" dirty="0">
-                          <a:latin typeface="Arial"/>
-                          <a:ea typeface="Arial"/>
-                          <a:cs typeface="Arial"/>
-                          <a:sym typeface="Arial"/>
-                        </a:rPr>
-                        <a:t>}</a:t>
-                      </a:r>
-                      <a:r>
-                        <a:rPr lang="id" sz="600" u="none" strike="noStrike" cap="none" dirty="0">
-                          <a:latin typeface="Arial"/>
-                          <a:ea typeface="Arial"/>
-                          <a:cs typeface="Arial"/>
-                          <a:sym typeface="Arial"/>
-                        </a:rPr>
-                        <a:t> </a:t>
-                      </a:r>
-                      <a:endParaRPr sz="600" b="0" i="0" u="none" strike="noStrike" cap="none" dirty="0">
-                        <a:solidFill>
-                          <a:srgbClr val="000000"/>
-                        </a:solidFill>
-                        <a:latin typeface="Arial"/>
-                        <a:ea typeface="Arial"/>
-                        <a:cs typeface="Arial"/>
-                        <a:sym typeface="Arial"/>
-                      </a:endParaRPr>
-                    </a:p>
-                  </a:txBody>
-                  <a:tcPr marL="3800" marR="3800" marT="3800" marB="0" anchor="b">
-                    <a:solidFill>
-                      <a:srgbClr val="FDEADA"/>
-                    </a:solidFill>
-                  </a:tcPr>
-                </a:tc>
-                <a:extLst>
-                  <a:ext uri="{0D108BD9-81ED-4DB2-BD59-A6C34878D82A}">
-                    <a16:rowId xmlns:a16="http://schemas.microsoft.com/office/drawing/2014/main" val="3038792638"/>
-                  </a:ext>
-                </a:extLst>
-              </a:tr>
-              <a:tr h="116675">
-                <a:tc>
-                  <a:txBody>
-                    <a:bodyPr/>
-                    <a:lstStyle/>
-                    <a:p>
-                      <a:pPr marL="0" marR="0" lvl="0" indent="0" algn="l" rtl="0">
-                        <a:lnSpc>
-                          <a:spcPct val="100000"/>
-                        </a:lnSpc>
-                        <a:spcBef>
-                          <a:spcPts val="0"/>
-                        </a:spcBef>
-                        <a:spcAft>
-                          <a:spcPts val="0"/>
-                        </a:spcAft>
-                        <a:buNone/>
-                      </a:pPr>
-                      <a:r>
-                        <a:rPr lang="en-US" sz="600" b="0" i="0" u="none" strike="noStrike" cap="none" dirty="0">
-                          <a:solidFill>
-                            <a:srgbClr val="000000"/>
-                          </a:solidFill>
-                          <a:latin typeface="Arial"/>
-                          <a:ea typeface="Arial"/>
-                          <a:cs typeface="Arial"/>
-                          <a:sym typeface="Arial"/>
-                        </a:rPr>
-                        <a:t>PNS JPT </a:t>
-                      </a:r>
-                      <a:r>
-                        <a:rPr lang="en-US" sz="600" b="0" i="0" u="none" strike="noStrike" cap="none" dirty="0" err="1">
-                          <a:solidFill>
-                            <a:srgbClr val="000000"/>
-                          </a:solidFill>
-                          <a:latin typeface="Arial"/>
-                          <a:ea typeface="Arial"/>
-                          <a:cs typeface="Arial"/>
-                          <a:sym typeface="Arial"/>
-                        </a:rPr>
-                        <a:t>Pratama</a:t>
-                      </a:r>
-                      <a:endParaRPr sz="600" b="0" i="0" u="none" strike="noStrike" cap="none" dirty="0">
-                        <a:solidFill>
-                          <a:srgbClr val="000000"/>
-                        </a:solidFill>
-                        <a:latin typeface="Arial"/>
-                        <a:ea typeface="Arial"/>
-                        <a:cs typeface="Arial"/>
-                        <a:sym typeface="Arial"/>
-                      </a:endParaRPr>
-                    </a:p>
-                  </a:txBody>
-                  <a:tcPr marL="3800" marR="3800" marT="3800" marB="0" anchor="b">
-                    <a:solidFill>
-                      <a:srgbClr val="FDEADA"/>
-                    </a:solidFill>
-                  </a:tcPr>
-                </a:tc>
-                <a:tc>
-                  <a:txBody>
-                    <a:bodyPr/>
-                    <a:lstStyle/>
-                    <a:p>
-                      <a:pPr marL="0" marR="0" lvl="0" indent="0" algn="r" rtl="0">
-                        <a:lnSpc>
-                          <a:spcPct val="100000"/>
-                        </a:lnSpc>
-                        <a:spcBef>
-                          <a:spcPts val="0"/>
-                        </a:spcBef>
-                        <a:spcAft>
-                          <a:spcPts val="0"/>
-                        </a:spcAft>
-                        <a:buNone/>
-                      </a:pPr>
-                      <a:r>
-                        <a:rPr lang="en-US" sz="600" b="0" i="0" u="none" strike="noStrike" cap="none" dirty="0">
-                          <a:solidFill>
-                            <a:srgbClr val="000000"/>
-                          </a:solidFill>
-                          <a:latin typeface="Arial"/>
-                          <a:ea typeface="Arial"/>
-                          <a:cs typeface="Arial"/>
-                          <a:sym typeface="Arial"/>
-                        </a:rPr>
-                        <a:t>{</a:t>
-                      </a:r>
-                      <a:r>
-                        <a:rPr lang="en-US" sz="600" b="0" i="0" u="none" strike="noStrike" cap="none" dirty="0" err="1">
-                          <a:solidFill>
-                            <a:srgbClr val="000000"/>
-                          </a:solidFill>
-                          <a:latin typeface="Arial"/>
-                          <a:ea typeface="Arial"/>
-                          <a:cs typeface="Arial"/>
-                          <a:sym typeface="Arial"/>
-                        </a:rPr>
-                        <a:t>count_pratama</a:t>
-                      </a:r>
-                      <a:r>
-                        <a:rPr lang="en-US" sz="600" b="0" i="0" u="none" strike="noStrike" cap="none" dirty="0">
-                          <a:solidFill>
-                            <a:srgbClr val="000000"/>
-                          </a:solidFill>
-                          <a:latin typeface="Arial"/>
-                          <a:ea typeface="Arial"/>
-                          <a:cs typeface="Arial"/>
-                          <a:sym typeface="Arial"/>
-                        </a:rPr>
-                        <a:t>}</a:t>
-                      </a:r>
-                      <a:endParaRPr sz="600" b="0" i="0" u="none" strike="noStrike" cap="none" dirty="0">
-                        <a:solidFill>
-                          <a:srgbClr val="000000"/>
-                        </a:solidFill>
-                        <a:latin typeface="Arial"/>
-                        <a:ea typeface="Arial"/>
-                        <a:cs typeface="Arial"/>
-                        <a:sym typeface="Arial"/>
-                      </a:endParaRPr>
-                    </a:p>
-                  </a:txBody>
-                  <a:tcPr marL="3800" marR="3800" marT="3800" marB="0" anchor="b">
-                    <a:solidFill>
-                      <a:srgbClr val="FDEADA"/>
-                    </a:solidFill>
-                  </a:tcPr>
-                </a:tc>
-                <a:extLst>
-                  <a:ext uri="{0D108BD9-81ED-4DB2-BD59-A6C34878D82A}">
-                    <a16:rowId xmlns:a16="http://schemas.microsoft.com/office/drawing/2014/main" val="10001"/>
-                  </a:ext>
-                </a:extLst>
-              </a:tr>
-              <a:tr h="116675">
-                <a:tc>
-                  <a:txBody>
-                    <a:bodyPr/>
-                    <a:lstStyle/>
-                    <a:p>
-                      <a:pPr marL="0" marR="0" lvl="0" indent="0" algn="l" rtl="0">
-                        <a:lnSpc>
-                          <a:spcPct val="100000"/>
-                        </a:lnSpc>
-                        <a:spcBef>
-                          <a:spcPts val="0"/>
-                        </a:spcBef>
-                        <a:spcAft>
-                          <a:spcPts val="0"/>
-                        </a:spcAft>
-                        <a:buNone/>
-                      </a:pPr>
-                      <a:r>
-                        <a:rPr lang="en-US" sz="600" u="none" strike="noStrike" cap="none" dirty="0">
-                          <a:latin typeface="Arial"/>
-                          <a:ea typeface="Arial"/>
-                          <a:cs typeface="Arial"/>
-                          <a:sym typeface="Arial"/>
-                        </a:rPr>
-                        <a:t>Administrator</a:t>
-                      </a:r>
-                      <a:endParaRPr lang="en-US" sz="600" b="0" i="0" u="none" strike="noStrike" cap="none" dirty="0">
-                        <a:solidFill>
-                          <a:srgbClr val="000000"/>
-                        </a:solidFill>
-                        <a:latin typeface="Arial"/>
-                        <a:ea typeface="Arial"/>
-                        <a:cs typeface="Arial"/>
-                        <a:sym typeface="Arial"/>
-                      </a:endParaRPr>
-                    </a:p>
-                  </a:txBody>
-                  <a:tcPr marL="3800" marR="3800" marT="3800" marB="0" anchor="b">
-                    <a:solidFill>
-                      <a:srgbClr val="FDEADA"/>
-                    </a:solidFill>
-                  </a:tcPr>
-                </a:tc>
-                <a:tc>
-                  <a:txBody>
-                    <a:bodyPr/>
-                    <a:lstStyle/>
-                    <a:p>
-                      <a:pPr marL="0" marR="0" lvl="0" indent="0" algn="r" rtl="0">
-                        <a:lnSpc>
-                          <a:spcPct val="100000"/>
-                        </a:lnSpc>
-                        <a:spcBef>
-                          <a:spcPts val="0"/>
-                        </a:spcBef>
-                        <a:spcAft>
-                          <a:spcPts val="0"/>
-                        </a:spcAft>
-                        <a:buNone/>
-                      </a:pPr>
-                      <a:r>
-                        <a:rPr lang="en-US" sz="600" u="none" strike="noStrike" cap="none" dirty="0">
-                          <a:latin typeface="Arial"/>
-                          <a:ea typeface="Arial"/>
-                          <a:cs typeface="Arial"/>
-                          <a:sym typeface="Arial"/>
-                        </a:rPr>
-                        <a:t>{</a:t>
-                      </a:r>
-                      <a:r>
-                        <a:rPr lang="en-US" sz="600" u="none" strike="noStrike" cap="none" dirty="0" err="1">
-                          <a:latin typeface="Arial"/>
-                          <a:ea typeface="Arial"/>
-                          <a:cs typeface="Arial"/>
-                          <a:sym typeface="Arial"/>
-                        </a:rPr>
-                        <a:t>count_administrator</a:t>
-                      </a:r>
-                      <a:r>
-                        <a:rPr lang="en-US" sz="600" u="none" strike="noStrike" cap="none" dirty="0">
-                          <a:latin typeface="Arial"/>
-                          <a:ea typeface="Arial"/>
-                          <a:cs typeface="Arial"/>
-                          <a:sym typeface="Arial"/>
-                        </a:rPr>
-                        <a:t>}</a:t>
-                      </a:r>
-                      <a:r>
-                        <a:rPr lang="id" sz="600" u="none" strike="noStrike" cap="none" dirty="0">
-                          <a:latin typeface="Arial"/>
-                          <a:ea typeface="Arial"/>
-                          <a:cs typeface="Arial"/>
-                          <a:sym typeface="Arial"/>
-                        </a:rPr>
-                        <a:t> </a:t>
-                      </a:r>
-                      <a:endParaRPr sz="600" b="0" i="0" u="none" strike="noStrike" cap="none" dirty="0">
-                        <a:solidFill>
-                          <a:srgbClr val="000000"/>
-                        </a:solidFill>
-                        <a:latin typeface="Arial"/>
-                        <a:ea typeface="Arial"/>
-                        <a:cs typeface="Arial"/>
-                        <a:sym typeface="Arial"/>
-                      </a:endParaRPr>
-                    </a:p>
-                  </a:txBody>
-                  <a:tcPr marL="3800" marR="3800" marT="3800" marB="0" anchor="b">
-                    <a:solidFill>
-                      <a:srgbClr val="FDEADA"/>
-                    </a:solidFill>
-                  </a:tcPr>
-                </a:tc>
-                <a:extLst>
-                  <a:ext uri="{0D108BD9-81ED-4DB2-BD59-A6C34878D82A}">
-                    <a16:rowId xmlns:a16="http://schemas.microsoft.com/office/drawing/2014/main" val="1294836286"/>
-                  </a:ext>
-                </a:extLst>
-              </a:tr>
-              <a:tr h="116675">
-                <a:tc>
-                  <a:txBody>
-                    <a:bodyPr/>
-                    <a:lstStyle/>
-                    <a:p>
-                      <a:pPr marL="0" marR="0" lvl="0" indent="0" algn="l" rtl="0">
-                        <a:lnSpc>
-                          <a:spcPct val="100000"/>
-                        </a:lnSpc>
-                        <a:spcBef>
-                          <a:spcPts val="0"/>
-                        </a:spcBef>
-                        <a:spcAft>
-                          <a:spcPts val="0"/>
-                        </a:spcAft>
-                        <a:buNone/>
-                      </a:pPr>
-                      <a:r>
-                        <a:rPr lang="en-US" sz="600" u="none" strike="noStrike" cap="none" dirty="0" err="1">
-                          <a:latin typeface="Arial"/>
-                          <a:ea typeface="Arial"/>
-                          <a:cs typeface="Arial"/>
-                          <a:sym typeface="Arial"/>
-                        </a:rPr>
-                        <a:t>Pengawas</a:t>
-                      </a:r>
-                      <a:endParaRPr lang="en-US" sz="600" b="0" i="0" u="none" strike="noStrike" cap="none" dirty="0">
-                        <a:solidFill>
-                          <a:srgbClr val="000000"/>
-                        </a:solidFill>
-                        <a:latin typeface="Arial"/>
-                        <a:ea typeface="Arial"/>
-                        <a:cs typeface="Arial"/>
-                        <a:sym typeface="Arial"/>
-                      </a:endParaRPr>
-                    </a:p>
-                  </a:txBody>
-                  <a:tcPr marL="3800" marR="3800" marT="3800" marB="0" anchor="b">
-                    <a:solidFill>
-                      <a:srgbClr val="FDEADA"/>
-                    </a:solidFill>
-                  </a:tcPr>
-                </a:tc>
-                <a:tc>
-                  <a:txBody>
-                    <a:bodyPr/>
-                    <a:lstStyle/>
-                    <a:p>
-                      <a:pPr marL="0" marR="0" lvl="0" indent="0" algn="r" rtl="0">
-                        <a:lnSpc>
-                          <a:spcPct val="100000"/>
-                        </a:lnSpc>
-                        <a:spcBef>
-                          <a:spcPts val="0"/>
-                        </a:spcBef>
-                        <a:spcAft>
-                          <a:spcPts val="0"/>
-                        </a:spcAft>
-                        <a:buNone/>
-                      </a:pPr>
-                      <a:r>
-                        <a:rPr lang="en-US" sz="600" u="none" strike="noStrike" cap="none" dirty="0">
-                          <a:latin typeface="Arial"/>
-                          <a:ea typeface="Arial"/>
-                          <a:cs typeface="Arial"/>
-                          <a:sym typeface="Arial"/>
-                        </a:rPr>
-                        <a:t>{</a:t>
-                      </a:r>
-                      <a:r>
-                        <a:rPr lang="en-US" sz="600" u="none" strike="noStrike" cap="none" dirty="0" err="1">
-                          <a:latin typeface="Arial"/>
-                          <a:ea typeface="Arial"/>
-                          <a:cs typeface="Arial"/>
-                          <a:sym typeface="Arial"/>
-                        </a:rPr>
-                        <a:t>count_pengawas</a:t>
-                      </a:r>
-                      <a:r>
-                        <a:rPr lang="en-US" sz="600" u="none" strike="noStrike" cap="none" dirty="0">
-                          <a:latin typeface="Arial"/>
-                          <a:ea typeface="Arial"/>
-                          <a:cs typeface="Arial"/>
-                          <a:sym typeface="Arial"/>
-                        </a:rPr>
-                        <a:t>}</a:t>
-                      </a:r>
-                      <a:r>
-                        <a:rPr lang="id" sz="600" u="none" strike="noStrike" cap="none" dirty="0">
-                          <a:latin typeface="Arial"/>
-                          <a:ea typeface="Arial"/>
-                          <a:cs typeface="Arial"/>
-                          <a:sym typeface="Arial"/>
-                        </a:rPr>
-                        <a:t> </a:t>
-                      </a:r>
-                      <a:endParaRPr sz="600" b="0" i="0" u="none" strike="noStrike" cap="none" dirty="0">
-                        <a:solidFill>
-                          <a:srgbClr val="000000"/>
-                        </a:solidFill>
-                        <a:latin typeface="Arial"/>
-                        <a:ea typeface="Arial"/>
-                        <a:cs typeface="Arial"/>
-                        <a:sym typeface="Arial"/>
-                      </a:endParaRPr>
-                    </a:p>
-                  </a:txBody>
-                  <a:tcPr marL="3800" marR="3800" marT="3800" marB="0" anchor="b">
-                    <a:solidFill>
-                      <a:srgbClr val="FDEADA"/>
-                    </a:solidFill>
-                  </a:tcPr>
-                </a:tc>
-                <a:extLst>
-                  <a:ext uri="{0D108BD9-81ED-4DB2-BD59-A6C34878D82A}">
-                    <a16:rowId xmlns:a16="http://schemas.microsoft.com/office/drawing/2014/main" val="4195108902"/>
-                  </a:ext>
-                </a:extLst>
-              </a:tr>
-              <a:tr h="116675">
-                <a:tc>
-                  <a:txBody>
-                    <a:bodyPr/>
-                    <a:lstStyle/>
-                    <a:p>
-                      <a:pPr marL="0" marR="0" lvl="0" indent="0" algn="l" rtl="0">
-                        <a:lnSpc>
-                          <a:spcPct val="100000"/>
-                        </a:lnSpc>
-                        <a:spcBef>
-                          <a:spcPts val="0"/>
-                        </a:spcBef>
-                        <a:spcAft>
-                          <a:spcPts val="0"/>
-                        </a:spcAft>
-                        <a:buNone/>
-                      </a:pPr>
-                      <a:r>
-                        <a:rPr lang="en-US" sz="600" u="none" strike="noStrike" cap="none" dirty="0" err="1">
-                          <a:latin typeface="Arial"/>
-                          <a:ea typeface="Arial"/>
-                          <a:cs typeface="Arial"/>
-                          <a:sym typeface="Arial"/>
-                        </a:rPr>
-                        <a:t>Eselon</a:t>
-                      </a:r>
-                      <a:r>
-                        <a:rPr lang="en-US" sz="600" u="none" strike="noStrike" cap="none" dirty="0">
-                          <a:latin typeface="Arial"/>
-                          <a:ea typeface="Arial"/>
-                          <a:cs typeface="Arial"/>
-                          <a:sym typeface="Arial"/>
-                        </a:rPr>
-                        <a:t> V</a:t>
-                      </a:r>
-                      <a:endParaRPr lang="en-US" sz="600" b="0" i="0" u="none" strike="noStrike" cap="none" dirty="0">
-                        <a:solidFill>
-                          <a:srgbClr val="000000"/>
-                        </a:solidFill>
-                        <a:latin typeface="Arial"/>
-                        <a:ea typeface="Arial"/>
-                        <a:cs typeface="Arial"/>
-                        <a:sym typeface="Arial"/>
-                      </a:endParaRPr>
-                    </a:p>
-                  </a:txBody>
-                  <a:tcPr marL="3800" marR="3800" marT="3800" marB="0" anchor="b">
-                    <a:solidFill>
-                      <a:srgbClr val="FDEADA"/>
-                    </a:solidFill>
-                  </a:tcPr>
-                </a:tc>
-                <a:tc>
-                  <a:txBody>
-                    <a:bodyPr/>
-                    <a:lstStyle/>
-                    <a:p>
-                      <a:pPr marL="0" marR="0" lvl="0" indent="0" algn="r" rtl="0">
-                        <a:lnSpc>
-                          <a:spcPct val="100000"/>
-                        </a:lnSpc>
-                        <a:spcBef>
-                          <a:spcPts val="0"/>
-                        </a:spcBef>
-                        <a:spcAft>
-                          <a:spcPts val="0"/>
-                        </a:spcAft>
-                        <a:buNone/>
-                      </a:pPr>
-                      <a:r>
-                        <a:rPr lang="en-US" sz="600" u="none" strike="noStrike" cap="none" dirty="0">
-                          <a:latin typeface="Arial"/>
-                          <a:ea typeface="Arial"/>
-                          <a:cs typeface="Arial"/>
-                          <a:sym typeface="Arial"/>
-                        </a:rPr>
-                        <a:t>{</a:t>
-                      </a:r>
-                      <a:r>
-                        <a:rPr lang="en-US" sz="600" u="none" strike="noStrike" cap="none" dirty="0" err="1">
-                          <a:latin typeface="Arial"/>
-                          <a:ea typeface="Arial"/>
-                          <a:cs typeface="Arial"/>
-                          <a:sym typeface="Arial"/>
-                        </a:rPr>
-                        <a:t>count_eselon</a:t>
-                      </a:r>
-                      <a:r>
-                        <a:rPr lang="en-US" sz="600" u="none" strike="noStrike" cap="none" dirty="0">
-                          <a:latin typeface="Arial"/>
-                          <a:ea typeface="Arial"/>
-                          <a:cs typeface="Arial"/>
-                          <a:sym typeface="Arial"/>
-                        </a:rPr>
-                        <a:t>}</a:t>
-                      </a:r>
-                      <a:r>
-                        <a:rPr lang="id" sz="600" u="none" strike="noStrike" cap="none" dirty="0">
-                          <a:latin typeface="Arial"/>
-                          <a:ea typeface="Arial"/>
-                          <a:cs typeface="Arial"/>
-                          <a:sym typeface="Arial"/>
-                        </a:rPr>
-                        <a:t> </a:t>
-                      </a:r>
-                      <a:endParaRPr sz="600" b="0" i="0" u="none" strike="noStrike" cap="none" dirty="0">
-                        <a:solidFill>
-                          <a:srgbClr val="000000"/>
-                        </a:solidFill>
-                        <a:latin typeface="Arial"/>
-                        <a:ea typeface="Arial"/>
-                        <a:cs typeface="Arial"/>
-                        <a:sym typeface="Arial"/>
-                      </a:endParaRPr>
-                    </a:p>
-                  </a:txBody>
-                  <a:tcPr marL="3800" marR="3800" marT="3800" marB="0" anchor="b">
-                    <a:solidFill>
-                      <a:srgbClr val="FDEADA"/>
-                    </a:solidFill>
-                  </a:tcPr>
-                </a:tc>
-                <a:extLst>
-                  <a:ext uri="{0D108BD9-81ED-4DB2-BD59-A6C34878D82A}">
-                    <a16:rowId xmlns:a16="http://schemas.microsoft.com/office/drawing/2014/main" val="10002"/>
-                  </a:ext>
-                </a:extLst>
-              </a:tr>
-            </a:tbl>
-          </a:graphicData>
-        </a:graphic>
-      </p:graphicFrame>
-      <p:graphicFrame>
-        <p:nvGraphicFramePr>
-          <p:cNvPr id="792" name="table_6"/>
-          <p:cNvGraphicFramePr/>
-          <p:nvPr>
-            <p:extLst>
-              <p:ext uri="{D42A27DB-BD31-4B8C-83A1-F6EECF244321}">
-                <p14:modId xmlns:p14="http://schemas.microsoft.com/office/powerpoint/2010/main" val="854458162"/>
-              </p:ext>
-            </p:extLst>
-          </p:nvPr>
-        </p:nvGraphicFramePr>
-        <p:xfrm>
-          <a:off x="6355270" y="3598026"/>
-          <a:ext cx="1265350" cy="1523622"/>
-        </p:xfrm>
-        <a:graphic>
-          <a:graphicData uri="http://schemas.openxmlformats.org/drawingml/2006/table">
-            <a:tbl>
-              <a:tblPr>
-                <a:noFill/>
-                <a:tableStyleId>{43F93C65-BEC1-43AD-96CD-C93F1471F904}</a:tableStyleId>
-              </a:tblPr>
-              <a:tblGrid>
-                <a:gridCol w="928075">
-                  <a:extLst>
-                    <a:ext uri="{9D8B030D-6E8A-4147-A177-3AD203B41FA5}">
-                      <a16:colId xmlns:a16="http://schemas.microsoft.com/office/drawing/2014/main" val="20000"/>
-                    </a:ext>
-                  </a:extLst>
-                </a:gridCol>
-                <a:gridCol w="337275">
-                  <a:extLst>
-                    <a:ext uri="{9D8B030D-6E8A-4147-A177-3AD203B41FA5}">
-                      <a16:colId xmlns:a16="http://schemas.microsoft.com/office/drawing/2014/main" val="20001"/>
-                    </a:ext>
-                  </a:extLst>
-                </a:gridCol>
-              </a:tblGrid>
-              <a:tr h="125850">
-                <a:tc>
-                  <a:txBody>
-                    <a:bodyPr/>
-                    <a:lstStyle/>
-                    <a:p>
-                      <a:pPr marL="0" marR="0" lvl="0" indent="0" algn="l" rtl="0">
-                        <a:lnSpc>
-                          <a:spcPct val="100000"/>
-                        </a:lnSpc>
-                        <a:spcBef>
-                          <a:spcPts val="0"/>
-                        </a:spcBef>
-                        <a:spcAft>
-                          <a:spcPts val="0"/>
-                        </a:spcAft>
-                        <a:buNone/>
-                      </a:pPr>
-                      <a:r>
-                        <a:rPr lang="id" sz="600" dirty="0">
-                          <a:solidFill>
-                            <a:srgbClr val="000000"/>
-                          </a:solidFill>
-                        </a:rPr>
-                        <a:t>PNS JF </a:t>
-                      </a:r>
-                      <a:r>
-                        <a:rPr lang="en-US" sz="600" dirty="0">
-                          <a:solidFill>
-                            <a:srgbClr val="000000"/>
-                          </a:solidFill>
-                        </a:rPr>
-                        <a:t>Guru</a:t>
-                      </a:r>
-                      <a:endParaRPr sz="600" b="0" i="0" u="none" strike="noStrike" cap="none" dirty="0">
-                        <a:solidFill>
-                          <a:srgbClr val="000000"/>
-                        </a:solidFill>
-                        <a:latin typeface="Arial"/>
-                        <a:ea typeface="Arial"/>
-                        <a:cs typeface="Arial"/>
-                        <a:sym typeface="Arial"/>
-                      </a:endParaRPr>
-                    </a:p>
-                  </a:txBody>
-                  <a:tcPr marL="0" marR="36000" marT="0" marB="0" anchor="ctr">
-                    <a:solidFill>
-                      <a:srgbClr val="F8D0DD"/>
-                    </a:solidFill>
-                  </a:tcPr>
-                </a:tc>
-                <a:tc>
-                  <a:txBody>
-                    <a:bodyPr/>
-                    <a:lstStyle/>
-                    <a:p>
-                      <a:pPr marL="0" marR="0" lvl="0" indent="0" algn="r" rtl="0">
-                        <a:lnSpc>
-                          <a:spcPct val="115000"/>
-                        </a:lnSpc>
-                        <a:spcBef>
-                          <a:spcPts val="0"/>
-                        </a:spcBef>
-                        <a:spcAft>
-                          <a:spcPts val="0"/>
-                        </a:spcAft>
-                        <a:buNone/>
-                      </a:pPr>
-                      <a:r>
-                        <a:rPr lang="en-US" sz="600" b="0" i="0" u="none" strike="noStrike" cap="none" dirty="0">
-                          <a:solidFill>
-                            <a:srgbClr val="000000"/>
-                          </a:solidFill>
-                          <a:latin typeface="Arial"/>
-                          <a:ea typeface="Arial"/>
-                          <a:cs typeface="Arial"/>
-                          <a:sym typeface="Arial"/>
-                        </a:rPr>
-                        <a:t>{</a:t>
-                      </a:r>
-                      <a:r>
-                        <a:rPr lang="en-US" sz="600" b="0" i="0" u="none" strike="noStrike" cap="none" dirty="0" err="1">
-                          <a:solidFill>
-                            <a:srgbClr val="000000"/>
-                          </a:solidFill>
-                          <a:latin typeface="Arial"/>
-                          <a:ea typeface="Arial"/>
-                          <a:cs typeface="Arial"/>
-                          <a:sym typeface="Arial"/>
-                        </a:rPr>
-                        <a:t>count_jf_guru</a:t>
-                      </a:r>
-                      <a:r>
-                        <a:rPr lang="en-US" sz="600" b="0" i="0" u="none" strike="noStrike" cap="none" dirty="0">
-                          <a:solidFill>
-                            <a:srgbClr val="000000"/>
-                          </a:solidFill>
-                          <a:latin typeface="Arial"/>
-                          <a:ea typeface="Arial"/>
-                          <a:cs typeface="Arial"/>
-                          <a:sym typeface="Arial"/>
-                        </a:rPr>
-                        <a:t>}</a:t>
-                      </a:r>
-                      <a:endParaRPr sz="600" b="0" i="0" u="none" strike="noStrike" cap="none" dirty="0">
-                        <a:solidFill>
-                          <a:srgbClr val="000000"/>
-                        </a:solidFill>
-                        <a:latin typeface="Arial"/>
-                        <a:ea typeface="Arial"/>
-                        <a:cs typeface="Arial"/>
-                        <a:sym typeface="Arial"/>
-                      </a:endParaRPr>
-                    </a:p>
-                  </a:txBody>
-                  <a:tcPr marL="0" marR="36000" marT="0" marB="0" anchor="ctr">
-                    <a:solidFill>
-                      <a:srgbClr val="F8D0DD"/>
-                    </a:solidFill>
-                  </a:tcPr>
-                </a:tc>
-                <a:extLst>
-                  <a:ext uri="{0D108BD9-81ED-4DB2-BD59-A6C34878D82A}">
-                    <a16:rowId xmlns:a16="http://schemas.microsoft.com/office/drawing/2014/main" val="10000"/>
-                  </a:ext>
-                </a:extLst>
-              </a:tr>
-              <a:tr h="125850">
-                <a:tc>
-                  <a:txBody>
-                    <a:bodyPr/>
-                    <a:lstStyle/>
-                    <a:p>
-                      <a:pPr marL="0" marR="0" lvl="0" indent="0" algn="l" rtl="0">
-                        <a:lnSpc>
-                          <a:spcPct val="100000"/>
-                        </a:lnSpc>
-                        <a:spcBef>
-                          <a:spcPts val="0"/>
-                        </a:spcBef>
-                        <a:spcAft>
-                          <a:spcPts val="0"/>
-                        </a:spcAft>
-                        <a:buNone/>
-                      </a:pPr>
-                      <a:r>
-                        <a:rPr lang="id" sz="600" u="none" strike="noStrike" cap="none">
-                          <a:latin typeface="Arial"/>
-                          <a:ea typeface="Arial"/>
-                          <a:cs typeface="Arial"/>
-                          <a:sym typeface="Arial"/>
-                        </a:rPr>
-                        <a:t>PNS JF Medis</a:t>
-                      </a:r>
-                      <a:endParaRPr sz="600" b="0" i="0" u="none" strike="noStrike" cap="none">
-                        <a:solidFill>
-                          <a:srgbClr val="000000"/>
-                        </a:solidFill>
-                        <a:latin typeface="Arial"/>
-                        <a:ea typeface="Arial"/>
-                        <a:cs typeface="Arial"/>
-                        <a:sym typeface="Arial"/>
-                      </a:endParaRPr>
-                    </a:p>
-                  </a:txBody>
-                  <a:tcPr marL="0" marR="36000" marT="0" marB="0" anchor="ctr">
-                    <a:solidFill>
-                      <a:srgbClr val="F8D0DD"/>
-                    </a:solidFill>
-                  </a:tcPr>
-                </a:tc>
-                <a:tc>
-                  <a:txBody>
-                    <a:bodyPr/>
-                    <a:lstStyle/>
-                    <a:p>
-                      <a:pPr marL="0" lvl="0" indent="0" algn="r" rtl="0">
-                        <a:lnSpc>
-                          <a:spcPct val="115000"/>
-                        </a:lnSpc>
-                        <a:spcBef>
-                          <a:spcPts val="0"/>
-                        </a:spcBef>
-                        <a:spcAft>
-                          <a:spcPts val="0"/>
-                        </a:spcAft>
-                        <a:buNone/>
-                      </a:pPr>
-                      <a:r>
-                        <a:rPr lang="en-US" sz="600" dirty="0"/>
-                        <a:t>{</a:t>
-                      </a:r>
-                      <a:r>
-                        <a:rPr lang="en-US" sz="600" dirty="0" err="1"/>
-                        <a:t>count_jf_medis</a:t>
-                      </a:r>
-                      <a:r>
-                        <a:rPr lang="en-US" sz="600" dirty="0"/>
-                        <a:t>}</a:t>
-                      </a:r>
-                      <a:endParaRPr sz="600" dirty="0"/>
-                    </a:p>
-                  </a:txBody>
-                  <a:tcPr marL="0" marR="36000" marT="0" marB="0" anchor="ctr">
-                    <a:solidFill>
-                      <a:srgbClr val="F8D0DD"/>
-                    </a:solidFill>
-                  </a:tcPr>
-                </a:tc>
-                <a:extLst>
-                  <a:ext uri="{0D108BD9-81ED-4DB2-BD59-A6C34878D82A}">
-                    <a16:rowId xmlns:a16="http://schemas.microsoft.com/office/drawing/2014/main" val="10001"/>
-                  </a:ext>
-                </a:extLst>
-              </a:tr>
-              <a:tr h="125850">
-                <a:tc>
-                  <a:txBody>
-                    <a:bodyPr/>
-                    <a:lstStyle/>
-                    <a:p>
-                      <a:pPr marL="0" marR="0" lvl="0" indent="0" algn="l" rtl="0">
-                        <a:lnSpc>
-                          <a:spcPct val="100000"/>
-                        </a:lnSpc>
-                        <a:spcBef>
-                          <a:spcPts val="0"/>
-                        </a:spcBef>
-                        <a:spcAft>
-                          <a:spcPts val="0"/>
-                        </a:spcAft>
-                        <a:buNone/>
-                      </a:pPr>
-                      <a:r>
-                        <a:rPr lang="id" sz="600" u="none" strike="noStrike" cap="none" dirty="0">
-                          <a:latin typeface="Arial"/>
-                          <a:ea typeface="Arial"/>
-                          <a:cs typeface="Arial"/>
-                          <a:sym typeface="Arial"/>
-                        </a:rPr>
-                        <a:t>PNS JF Teknis</a:t>
-                      </a:r>
-                      <a:endParaRPr sz="600" b="0" i="0" u="none" strike="noStrike" cap="none" dirty="0">
-                        <a:solidFill>
-                          <a:srgbClr val="000000"/>
-                        </a:solidFill>
-                        <a:latin typeface="Arial"/>
-                        <a:ea typeface="Arial"/>
-                        <a:cs typeface="Arial"/>
-                        <a:sym typeface="Arial"/>
-                      </a:endParaRPr>
-                    </a:p>
-                  </a:txBody>
-                  <a:tcPr marL="0" marR="36000" marT="0" marB="0" anchor="ctr">
-                    <a:solidFill>
-                      <a:srgbClr val="F8D0DD"/>
-                    </a:solidFill>
-                  </a:tcPr>
-                </a:tc>
-                <a:tc>
-                  <a:txBody>
-                    <a:bodyPr/>
-                    <a:lstStyle/>
-                    <a:p>
-                      <a:pPr marL="0" lvl="0" indent="0" algn="r" rtl="0">
-                        <a:lnSpc>
-                          <a:spcPct val="115000"/>
-                        </a:lnSpc>
-                        <a:spcBef>
-                          <a:spcPts val="0"/>
-                        </a:spcBef>
-                        <a:spcAft>
-                          <a:spcPts val="0"/>
-                        </a:spcAft>
-                        <a:buNone/>
-                      </a:pPr>
-                      <a:r>
-                        <a:rPr lang="en-US" sz="600" dirty="0"/>
-                        <a:t>{</a:t>
-                      </a:r>
-                      <a:r>
-                        <a:rPr lang="en-US" sz="600" dirty="0" err="1"/>
-                        <a:t>count_jf_teknis</a:t>
-                      </a:r>
-                      <a:r>
-                        <a:rPr lang="en-US" sz="600" dirty="0"/>
-                        <a:t>}</a:t>
-                      </a:r>
-                      <a:endParaRPr sz="600" dirty="0"/>
-                    </a:p>
-                  </a:txBody>
-                  <a:tcPr marL="0" marR="36000" marT="0" marB="0" anchor="ctr">
-                    <a:solidFill>
-                      <a:srgbClr val="F8D0DD"/>
-                    </a:solidFill>
-                  </a:tcPr>
-                </a:tc>
-                <a:extLst>
-                  <a:ext uri="{0D108BD9-81ED-4DB2-BD59-A6C34878D82A}">
-                    <a16:rowId xmlns:a16="http://schemas.microsoft.com/office/drawing/2014/main" val="10002"/>
-                  </a:ext>
-                </a:extLst>
-              </a:tr>
-              <a:tr h="107500">
-                <a:tc>
-                  <a:txBody>
-                    <a:bodyPr/>
-                    <a:lstStyle/>
-                    <a:p>
-                      <a:pPr marL="0" marR="0" lvl="0" indent="0" algn="l" rtl="0">
-                        <a:lnSpc>
-                          <a:spcPct val="100000"/>
-                        </a:lnSpc>
-                        <a:spcBef>
-                          <a:spcPts val="0"/>
-                        </a:spcBef>
-                        <a:spcAft>
-                          <a:spcPts val="0"/>
-                        </a:spcAft>
-                        <a:buNone/>
-                      </a:pPr>
-                      <a:r>
-                        <a:rPr lang="id" sz="600" u="none" strike="noStrike" cap="none" dirty="0">
-                          <a:latin typeface="Arial"/>
-                          <a:ea typeface="Arial"/>
-                          <a:cs typeface="Arial"/>
-                          <a:sym typeface="Arial"/>
-                        </a:rPr>
-                        <a:t>PPPK </a:t>
-                      </a:r>
-                      <a:r>
-                        <a:rPr lang="en-US" sz="600" u="none" strike="noStrike" cap="none" dirty="0">
-                          <a:latin typeface="Arial"/>
-                          <a:ea typeface="Arial"/>
-                          <a:cs typeface="Arial"/>
-                          <a:sym typeface="Arial"/>
-                        </a:rPr>
-                        <a:t>JF Guru</a:t>
-                      </a:r>
-                      <a:endParaRPr sz="600" b="0" i="0" u="none" strike="noStrike" cap="none" dirty="0">
-                        <a:solidFill>
-                          <a:srgbClr val="000000"/>
-                        </a:solidFill>
-                        <a:latin typeface="Arial"/>
-                        <a:ea typeface="Arial"/>
-                        <a:cs typeface="Arial"/>
-                        <a:sym typeface="Arial"/>
-                      </a:endParaRPr>
-                    </a:p>
-                  </a:txBody>
-                  <a:tcPr marL="0" marR="36000" marT="0" marB="0" anchor="ctr">
-                    <a:solidFill>
-                      <a:srgbClr val="D0E0E3"/>
-                    </a:solidFill>
-                  </a:tcPr>
-                </a:tc>
-                <a:tc>
-                  <a:txBody>
-                    <a:bodyPr/>
-                    <a:lstStyle/>
-                    <a:p>
-                      <a:pPr marL="0" lvl="0" indent="0" algn="r" rtl="0">
-                        <a:lnSpc>
-                          <a:spcPct val="115000"/>
-                        </a:lnSpc>
-                        <a:spcBef>
-                          <a:spcPts val="0"/>
-                        </a:spcBef>
-                        <a:spcAft>
-                          <a:spcPts val="0"/>
-                        </a:spcAft>
-                        <a:buNone/>
-                      </a:pPr>
-                      <a:r>
-                        <a:rPr lang="en-US" sz="600" dirty="0"/>
-                        <a:t>{</a:t>
-                      </a:r>
-                      <a:r>
-                        <a:rPr lang="en-US" sz="600" dirty="0" err="1"/>
-                        <a:t>count_pppk_guru</a:t>
-                      </a:r>
-                      <a:r>
-                        <a:rPr lang="en-US" sz="600" dirty="0"/>
-                        <a:t>}</a:t>
-                      </a:r>
-                      <a:endParaRPr sz="600" dirty="0"/>
-                    </a:p>
-                  </a:txBody>
-                  <a:tcPr marL="0" marR="36000" marT="0" marB="0" anchor="ctr">
-                    <a:solidFill>
-                      <a:srgbClr val="D0E0E3"/>
-                    </a:solidFill>
-                  </a:tcPr>
-                </a:tc>
-                <a:extLst>
-                  <a:ext uri="{0D108BD9-81ED-4DB2-BD59-A6C34878D82A}">
-                    <a16:rowId xmlns:a16="http://schemas.microsoft.com/office/drawing/2014/main" val="10003"/>
-                  </a:ext>
-                </a:extLst>
-              </a:tr>
-              <a:tr h="107500">
-                <a:tc>
-                  <a:txBody>
-                    <a:bodyPr/>
-                    <a:lstStyle/>
-                    <a:p>
-                      <a:pPr marL="0" marR="0" lvl="0" indent="0" algn="l" rtl="0">
-                        <a:lnSpc>
-                          <a:spcPct val="100000"/>
-                        </a:lnSpc>
-                        <a:spcBef>
-                          <a:spcPts val="0"/>
-                        </a:spcBef>
-                        <a:spcAft>
-                          <a:spcPts val="0"/>
-                        </a:spcAft>
-                        <a:buNone/>
-                      </a:pPr>
-                      <a:r>
-                        <a:rPr lang="id" sz="600" b="0" i="0" u="none" strike="noStrike" cap="none" dirty="0">
-                          <a:solidFill>
-                            <a:srgbClr val="000000"/>
-                          </a:solidFill>
-                          <a:latin typeface="Arial"/>
-                          <a:ea typeface="Arial"/>
-                          <a:cs typeface="Arial"/>
-                          <a:sym typeface="Arial"/>
-                        </a:rPr>
-                        <a:t>PPPK </a:t>
-                      </a:r>
-                      <a:r>
-                        <a:rPr lang="en-US" sz="600" b="0" i="0" u="none" strike="noStrike" cap="none" dirty="0">
-                          <a:solidFill>
-                            <a:srgbClr val="000000"/>
-                          </a:solidFill>
-                          <a:latin typeface="Arial"/>
-                          <a:ea typeface="Arial"/>
-                          <a:cs typeface="Arial"/>
-                          <a:sym typeface="Arial"/>
-                        </a:rPr>
-                        <a:t>JF </a:t>
-                      </a:r>
-                      <a:r>
-                        <a:rPr lang="en-US" sz="600" b="0" i="0" u="none" strike="noStrike" cap="none" dirty="0" err="1">
-                          <a:solidFill>
-                            <a:srgbClr val="000000"/>
-                          </a:solidFill>
-                          <a:latin typeface="Arial"/>
-                          <a:ea typeface="Arial"/>
-                          <a:cs typeface="Arial"/>
-                          <a:sym typeface="Arial"/>
-                        </a:rPr>
-                        <a:t>Medis</a:t>
-                      </a:r>
-                      <a:endParaRPr sz="600" b="0" i="0" u="none" strike="noStrike" cap="none" dirty="0">
-                        <a:solidFill>
-                          <a:srgbClr val="000000"/>
-                        </a:solidFill>
-                        <a:latin typeface="Arial"/>
-                        <a:ea typeface="Arial"/>
-                        <a:cs typeface="Arial"/>
-                        <a:sym typeface="Arial"/>
-                      </a:endParaRPr>
-                    </a:p>
-                  </a:txBody>
-                  <a:tcPr marL="0" marR="36000" marT="0" marB="0" anchor="ctr">
-                    <a:solidFill>
-                      <a:srgbClr val="D0E0E3"/>
-                    </a:solidFill>
-                  </a:tcPr>
-                </a:tc>
-                <a:tc>
-                  <a:txBody>
-                    <a:bodyPr/>
-                    <a:lstStyle/>
-                    <a:p>
-                      <a:pPr marL="0" lvl="0" indent="0" algn="r" rtl="0">
-                        <a:lnSpc>
-                          <a:spcPct val="115000"/>
-                        </a:lnSpc>
-                        <a:spcBef>
-                          <a:spcPts val="0"/>
-                        </a:spcBef>
-                        <a:spcAft>
-                          <a:spcPts val="0"/>
-                        </a:spcAft>
-                        <a:buNone/>
-                      </a:pPr>
-                      <a:r>
-                        <a:rPr lang="en-US" sz="600" dirty="0"/>
-                        <a:t>{</a:t>
-                      </a:r>
-                      <a:r>
-                        <a:rPr lang="en-US" sz="600" dirty="0" err="1"/>
-                        <a:t>count_pppk_medis</a:t>
-                      </a:r>
-                      <a:r>
-                        <a:rPr lang="en-US" sz="600" dirty="0"/>
-                        <a:t>}</a:t>
-                      </a:r>
-                      <a:endParaRPr sz="600" dirty="0"/>
-                    </a:p>
-                  </a:txBody>
-                  <a:tcPr marL="0" marR="36000" marT="0" marB="0" anchor="ctr">
-                    <a:solidFill>
-                      <a:srgbClr val="D0E0E3"/>
-                    </a:solidFill>
-                  </a:tcPr>
-                </a:tc>
-                <a:extLst>
-                  <a:ext uri="{0D108BD9-81ED-4DB2-BD59-A6C34878D82A}">
-                    <a16:rowId xmlns:a16="http://schemas.microsoft.com/office/drawing/2014/main" val="10004"/>
-                  </a:ext>
-                </a:extLst>
-              </a:tr>
-              <a:tr h="107500">
-                <a:tc>
-                  <a:txBody>
-                    <a:bodyPr/>
-                    <a:lstStyle/>
-                    <a:p>
-                      <a:pPr marL="0" marR="0" lvl="0" indent="0" algn="l" rtl="0">
-                        <a:lnSpc>
-                          <a:spcPct val="100000"/>
-                        </a:lnSpc>
-                        <a:spcBef>
-                          <a:spcPts val="0"/>
-                        </a:spcBef>
-                        <a:spcAft>
-                          <a:spcPts val="0"/>
-                        </a:spcAft>
-                        <a:buNone/>
-                      </a:pPr>
-                      <a:r>
-                        <a:rPr lang="id" sz="600" b="0" i="0" u="none" strike="noStrike" cap="none" dirty="0">
-                          <a:solidFill>
-                            <a:srgbClr val="000000"/>
-                          </a:solidFill>
-                          <a:latin typeface="Arial"/>
-                          <a:ea typeface="Arial"/>
-                          <a:cs typeface="Arial"/>
-                          <a:sym typeface="Arial"/>
-                        </a:rPr>
-                        <a:t>PPPK </a:t>
-                      </a:r>
-                      <a:r>
-                        <a:rPr lang="en-US" sz="600" b="0" i="0" u="none" strike="noStrike" cap="none" dirty="0">
-                          <a:solidFill>
-                            <a:srgbClr val="000000"/>
-                          </a:solidFill>
-                          <a:latin typeface="Arial"/>
-                          <a:ea typeface="Arial"/>
-                          <a:cs typeface="Arial"/>
-                          <a:sym typeface="Arial"/>
-                        </a:rPr>
-                        <a:t>JF </a:t>
-                      </a:r>
-                      <a:r>
-                        <a:rPr lang="id" sz="600" b="0" i="0" u="none" strike="noStrike" cap="none" dirty="0">
-                          <a:solidFill>
-                            <a:srgbClr val="000000"/>
-                          </a:solidFill>
-                          <a:latin typeface="Arial"/>
-                          <a:ea typeface="Arial"/>
-                          <a:cs typeface="Arial"/>
-                          <a:sym typeface="Arial"/>
-                        </a:rPr>
-                        <a:t>Teknis</a:t>
-                      </a:r>
-                      <a:endParaRPr sz="600" b="0" i="0" u="none" strike="noStrike" cap="none" dirty="0">
-                        <a:solidFill>
-                          <a:srgbClr val="000000"/>
-                        </a:solidFill>
-                        <a:latin typeface="Arial"/>
-                        <a:ea typeface="Arial"/>
-                        <a:cs typeface="Arial"/>
-                        <a:sym typeface="Arial"/>
-                      </a:endParaRPr>
-                    </a:p>
-                  </a:txBody>
-                  <a:tcPr marL="0" marR="36000" marT="0" marB="0" anchor="ctr">
-                    <a:solidFill>
-                      <a:srgbClr val="D0E0E3"/>
-                    </a:solidFill>
-                  </a:tcPr>
-                </a:tc>
-                <a:tc>
-                  <a:txBody>
-                    <a:bodyPr/>
-                    <a:lstStyle/>
-                    <a:p>
-                      <a:pPr marL="0" lvl="0" indent="0" algn="r" rtl="0">
-                        <a:lnSpc>
-                          <a:spcPct val="115000"/>
-                        </a:lnSpc>
-                        <a:spcBef>
-                          <a:spcPts val="0"/>
-                        </a:spcBef>
-                        <a:spcAft>
-                          <a:spcPts val="0"/>
-                        </a:spcAft>
-                        <a:buNone/>
-                      </a:pPr>
-                      <a:r>
-                        <a:rPr lang="en-US" sz="600" dirty="0"/>
-                        <a:t>{</a:t>
-                      </a:r>
-                      <a:r>
-                        <a:rPr lang="en-US" sz="600" dirty="0" err="1"/>
-                        <a:t>count_pppk_teknis</a:t>
-                      </a:r>
-                      <a:r>
-                        <a:rPr lang="en-US" sz="600" dirty="0"/>
-                        <a:t>}</a:t>
-                      </a:r>
-                      <a:endParaRPr sz="600" dirty="0"/>
-                    </a:p>
-                  </a:txBody>
-                  <a:tcPr marL="0" marR="36000" marT="0" marB="0" anchor="ctr">
-                    <a:solidFill>
-                      <a:srgbClr val="D0E0E3"/>
-                    </a:solidFill>
-                  </a:tcPr>
-                </a:tc>
-                <a:extLst>
-                  <a:ext uri="{0D108BD9-81ED-4DB2-BD59-A6C34878D82A}">
-                    <a16:rowId xmlns:a16="http://schemas.microsoft.com/office/drawing/2014/main" val="10005"/>
-                  </a:ext>
-                </a:extLst>
-              </a:tr>
-            </a:tbl>
-          </a:graphicData>
-        </a:graphic>
-      </p:graphicFrame>
       <p:sp>
         <p:nvSpPr>
           <p:cNvPr id="794" name="Google Shape;794;p75"/>
@@ -22479,7 +19488,7 @@
         <p:spPr>
           <a:xfrm>
             <a:off x="1267568" y="136550"/>
-            <a:ext cx="5463300" cy="615553"/>
+            <a:ext cx="5463300" cy="553998"/>
           </a:xfrm>
           <a:prstGeom prst="rect">
             <a:avLst/>
@@ -22508,7 +19517,7 @@
               <a:buNone/>
             </a:pPr>
             <a:r>
-              <a:rPr lang="id" sz="2000" b="1" dirty="0">
+              <a:rPr lang="id" sz="1800" b="1" dirty="0">
                 <a:solidFill>
                   <a:srgbClr val="193985"/>
                 </a:solidFill>
@@ -22520,7 +19529,7 @@
               <a:t>STATISTIK ASN</a:t>
             </a:r>
             <a:r>
-              <a:rPr lang="en-US" sz="2000" b="1" dirty="0">
+              <a:rPr lang="en-US" sz="1800" b="1" dirty="0">
                 <a:solidFill>
                   <a:srgbClr val="193985"/>
                 </a:solidFill>
@@ -22546,7 +19555,7 @@
               <a:buNone/>
             </a:pPr>
             <a:r>
-              <a:rPr lang="en-US" sz="2000" b="1" dirty="0">
+              <a:rPr lang="en-US" sz="1800" b="1" dirty="0">
                 <a:solidFill>
                   <a:srgbClr val="193985"/>
                 </a:solidFill>
@@ -22569,874 +19578,6 @@
           </a:p>
         </p:txBody>
       </p:sp>
-      <p:graphicFrame>
-        <p:nvGraphicFramePr>
-          <p:cNvPr id="2" name="table_2">
-            <a:extLst>
-              <a:ext uri="{FF2B5EF4-FFF2-40B4-BE49-F238E27FC236}">
-                <a16:creationId xmlns:a16="http://schemas.microsoft.com/office/drawing/2014/main" id="{5055B065-E905-4ED8-9E37-5B21B5A93AC9}"/>
-              </a:ext>
-            </a:extLst>
-          </p:cNvPr>
-          <p:cNvGraphicFramePr>
-            <a:graphicFrameLocks noGrp="1"/>
-          </p:cNvGraphicFramePr>
-          <p:nvPr>
-            <p:extLst>
-              <p:ext uri="{D42A27DB-BD31-4B8C-83A1-F6EECF244321}">
-                <p14:modId xmlns:p14="http://schemas.microsoft.com/office/powerpoint/2010/main" val="529540898"/>
-              </p:ext>
-            </p:extLst>
-          </p:nvPr>
-        </p:nvGraphicFramePr>
-        <p:xfrm>
-          <a:off x="1672540" y="3186690"/>
-          <a:ext cx="609600" cy="3520440"/>
-        </p:xfrm>
-        <a:graphic>
-          <a:graphicData uri="http://schemas.openxmlformats.org/drawingml/2006/table">
-            <a:tbl>
-              <a:tblPr>
-                <a:tableStyleId>{2460487B-A31E-4291-9FF1-7AE1C1612F53}</a:tableStyleId>
-              </a:tblPr>
-              <a:tblGrid>
-                <a:gridCol w="609600">
-                  <a:extLst>
-                    <a:ext uri="{9D8B030D-6E8A-4147-A177-3AD203B41FA5}">
-                      <a16:colId xmlns:a16="http://schemas.microsoft.com/office/drawing/2014/main" val="1548401398"/>
-                    </a:ext>
-                  </a:extLst>
-                </a:gridCol>
-              </a:tblGrid>
-              <a:tr h="155737">
-                <a:tc>
-                  <a:txBody>
-                    <a:bodyPr/>
-                    <a:lstStyle/>
-                    <a:p>
-                      <a:pPr algn="r" fontAlgn="b"/>
-                      <a:r>
-                        <a:rPr lang="en-US" sz="1100" b="1" i="0" u="none" strike="noStrike" dirty="0">
-                          <a:solidFill>
-                            <a:schemeClr val="accent5">
-                              <a:lumMod val="50000"/>
-                            </a:schemeClr>
-                          </a:solidFill>
-                          <a:effectLst/>
-                          <a:latin typeface="Calibri" panose="020F0502020204030204" pitchFamily="34" charset="0"/>
-                        </a:rPr>
-                        <a:t>{persentase_vis_0_5}</a:t>
-                      </a:r>
-                    </a:p>
-                  </a:txBody>
-                  <a:tcPr marL="7620" marR="7620" marT="0" marB="0" anchor="b">
-                    <a:lnL w="12700" cmpd="sng">
-                      <a:noFill/>
-                      <a:prstDash val="solid"/>
-                    </a:lnL>
-                    <a:lnR w="12700" cmpd="sng">
-                      <a:noFill/>
-                      <a:prstDash val="solid"/>
-                    </a:lnR>
-                    <a:lnT w="12700" cmpd="sng">
-                      <a:noFill/>
-                      <a:prstDash val="solid"/>
-                    </a:lnT>
-                    <a:lnB w="12700" cmpd="sng">
-                      <a:noFill/>
-                      <a:prstDash val="solid"/>
-                    </a:lnB>
-                    <a:lnTlToBr w="12700" cmpd="sng">
-                      <a:noFill/>
-                      <a:prstDash val="solid"/>
-                    </a:lnTlToBr>
-                    <a:lnBlToTr w="12700" cmpd="sng">
-                      <a:noFill/>
-                      <a:prstDash val="solid"/>
-                    </a:lnBlToTr>
-                  </a:tcPr>
-                </a:tc>
-                <a:extLst>
-                  <a:ext uri="{0D108BD9-81ED-4DB2-BD59-A6C34878D82A}">
-                    <a16:rowId xmlns:a16="http://schemas.microsoft.com/office/drawing/2014/main" val="3661126495"/>
-                  </a:ext>
-                </a:extLst>
-              </a:tr>
-              <a:tr h="155737">
-                <a:tc>
-                  <a:txBody>
-                    <a:bodyPr/>
-                    <a:lstStyle/>
-                    <a:p>
-                      <a:pPr algn="r" fontAlgn="b"/>
-                      <a:r>
-                        <a:rPr lang="en-US" sz="1100" b="1" i="0" u="none" strike="noStrike" dirty="0">
-                          <a:solidFill>
-                            <a:schemeClr val="accent5">
-                              <a:lumMod val="50000"/>
-                            </a:schemeClr>
-                          </a:solidFill>
-                          <a:effectLst/>
-                          <a:latin typeface="Calibri" panose="020F0502020204030204" pitchFamily="34" charset="0"/>
-                        </a:rPr>
-                        <a:t>{persentase_vis_6_10}</a:t>
-                      </a:r>
-                    </a:p>
-                  </a:txBody>
-                  <a:tcPr marL="7620" marR="7620" marT="0" marB="0" anchor="b">
-                    <a:lnL w="12700" cmpd="sng">
-                      <a:noFill/>
-                      <a:prstDash val="solid"/>
-                    </a:lnL>
-                    <a:lnR w="12700" cmpd="sng">
-                      <a:noFill/>
-                      <a:prstDash val="solid"/>
-                    </a:lnR>
-                    <a:lnT w="12700" cmpd="sng">
-                      <a:noFill/>
-                      <a:prstDash val="solid"/>
-                    </a:lnT>
-                    <a:lnB w="12700" cmpd="sng">
-                      <a:noFill/>
-                      <a:prstDash val="solid"/>
-                    </a:lnB>
-                    <a:lnTlToBr w="12700" cmpd="sng">
-                      <a:noFill/>
-                      <a:prstDash val="solid"/>
-                    </a:lnTlToBr>
-                    <a:lnBlToTr w="12700" cmpd="sng">
-                      <a:noFill/>
-                      <a:prstDash val="solid"/>
-                    </a:lnBlToTr>
-                  </a:tcPr>
-                </a:tc>
-                <a:extLst>
-                  <a:ext uri="{0D108BD9-81ED-4DB2-BD59-A6C34878D82A}">
-                    <a16:rowId xmlns:a16="http://schemas.microsoft.com/office/drawing/2014/main" val="3580170535"/>
-                  </a:ext>
-                </a:extLst>
-              </a:tr>
-              <a:tr h="155737">
-                <a:tc>
-                  <a:txBody>
-                    <a:bodyPr/>
-                    <a:lstStyle/>
-                    <a:p>
-                      <a:pPr algn="r" fontAlgn="b"/>
-                      <a:r>
-                        <a:rPr lang="en-US" sz="1100" b="1" i="0" u="none" strike="noStrike" dirty="0">
-                          <a:solidFill>
-                            <a:schemeClr val="accent5">
-                              <a:lumMod val="50000"/>
-                            </a:schemeClr>
-                          </a:solidFill>
-                          <a:effectLst/>
-                          <a:latin typeface="Calibri" panose="020F0502020204030204" pitchFamily="34" charset="0"/>
-                        </a:rPr>
-                        <a:t>{persentase_vis_11_15}</a:t>
-                      </a:r>
-                    </a:p>
-                  </a:txBody>
-                  <a:tcPr marL="7620" marR="7620" marT="0" marB="0" anchor="b">
-                    <a:lnL w="12700" cmpd="sng">
-                      <a:noFill/>
-                      <a:prstDash val="solid"/>
-                    </a:lnL>
-                    <a:lnR w="12700" cmpd="sng">
-                      <a:noFill/>
-                      <a:prstDash val="solid"/>
-                    </a:lnR>
-                    <a:lnT w="12700" cmpd="sng">
-                      <a:noFill/>
-                      <a:prstDash val="solid"/>
-                    </a:lnT>
-                    <a:lnB w="12700" cmpd="sng">
-                      <a:noFill/>
-                      <a:prstDash val="solid"/>
-                    </a:lnB>
-                    <a:lnTlToBr w="12700" cmpd="sng">
-                      <a:noFill/>
-                      <a:prstDash val="solid"/>
-                    </a:lnTlToBr>
-                    <a:lnBlToTr w="12700" cmpd="sng">
-                      <a:noFill/>
-                      <a:prstDash val="solid"/>
-                    </a:lnBlToTr>
-                  </a:tcPr>
-                </a:tc>
-                <a:extLst>
-                  <a:ext uri="{0D108BD9-81ED-4DB2-BD59-A6C34878D82A}">
-                    <a16:rowId xmlns:a16="http://schemas.microsoft.com/office/drawing/2014/main" val="2568679874"/>
-                  </a:ext>
-                </a:extLst>
-              </a:tr>
-              <a:tr h="155737">
-                <a:tc>
-                  <a:txBody>
-                    <a:bodyPr/>
-                    <a:lstStyle/>
-                    <a:p>
-                      <a:pPr algn="r" fontAlgn="b"/>
-                      <a:r>
-                        <a:rPr lang="en-US" sz="1100" b="1" i="0" u="none" strike="noStrike" dirty="0">
-                          <a:solidFill>
-                            <a:schemeClr val="accent5">
-                              <a:lumMod val="50000"/>
-                            </a:schemeClr>
-                          </a:solidFill>
-                          <a:effectLst/>
-                          <a:latin typeface="Calibri" panose="020F0502020204030204" pitchFamily="34" charset="0"/>
-                        </a:rPr>
-                        <a:t>{persentase_vis_16_20}</a:t>
-                      </a:r>
-                    </a:p>
-                  </a:txBody>
-                  <a:tcPr marL="7620" marR="7620" marT="0" marB="0" anchor="b">
-                    <a:lnL w="12700" cmpd="sng">
-                      <a:noFill/>
-                      <a:prstDash val="solid"/>
-                    </a:lnL>
-                    <a:lnR w="12700" cmpd="sng">
-                      <a:noFill/>
-                      <a:prstDash val="solid"/>
-                    </a:lnR>
-                    <a:lnT w="12700" cmpd="sng">
-                      <a:noFill/>
-                      <a:prstDash val="solid"/>
-                    </a:lnT>
-                    <a:lnB w="12700" cmpd="sng">
-                      <a:noFill/>
-                      <a:prstDash val="solid"/>
-                    </a:lnB>
-                    <a:lnTlToBr w="12700" cmpd="sng">
-                      <a:noFill/>
-                      <a:prstDash val="solid"/>
-                    </a:lnTlToBr>
-                    <a:lnBlToTr w="12700" cmpd="sng">
-                      <a:noFill/>
-                      <a:prstDash val="solid"/>
-                    </a:lnBlToTr>
-                  </a:tcPr>
-                </a:tc>
-                <a:extLst>
-                  <a:ext uri="{0D108BD9-81ED-4DB2-BD59-A6C34878D82A}">
-                    <a16:rowId xmlns:a16="http://schemas.microsoft.com/office/drawing/2014/main" val="975621839"/>
-                  </a:ext>
-                </a:extLst>
-              </a:tr>
-              <a:tr h="155737">
-                <a:tc>
-                  <a:txBody>
-                    <a:bodyPr/>
-                    <a:lstStyle/>
-                    <a:p>
-                      <a:pPr algn="r" fontAlgn="b"/>
-                      <a:r>
-                        <a:rPr lang="en-US" sz="1100" b="1" i="0" u="none" strike="noStrike" dirty="0">
-                          <a:solidFill>
-                            <a:schemeClr val="accent5">
-                              <a:lumMod val="50000"/>
-                            </a:schemeClr>
-                          </a:solidFill>
-                          <a:effectLst/>
-                          <a:latin typeface="Calibri" panose="020F0502020204030204" pitchFamily="34" charset="0"/>
-                        </a:rPr>
-                        <a:t>{persentase_vis_21_25}</a:t>
-                      </a:r>
-                    </a:p>
-                  </a:txBody>
-                  <a:tcPr marL="7620" marR="7620" marT="0" marB="0" anchor="b">
-                    <a:lnL w="12700" cmpd="sng">
-                      <a:noFill/>
-                      <a:prstDash val="solid"/>
-                    </a:lnL>
-                    <a:lnR w="12700" cmpd="sng">
-                      <a:noFill/>
-                      <a:prstDash val="solid"/>
-                    </a:lnR>
-                    <a:lnT w="12700" cmpd="sng">
-                      <a:noFill/>
-                      <a:prstDash val="solid"/>
-                    </a:lnT>
-                    <a:lnB w="12700" cmpd="sng">
-                      <a:noFill/>
-                      <a:prstDash val="solid"/>
-                    </a:lnB>
-                    <a:lnTlToBr w="12700" cmpd="sng">
-                      <a:noFill/>
-                      <a:prstDash val="solid"/>
-                    </a:lnTlToBr>
-                    <a:lnBlToTr w="12700" cmpd="sng">
-                      <a:noFill/>
-                      <a:prstDash val="solid"/>
-                    </a:lnBlToTr>
-                  </a:tcPr>
-                </a:tc>
-                <a:extLst>
-                  <a:ext uri="{0D108BD9-81ED-4DB2-BD59-A6C34878D82A}">
-                    <a16:rowId xmlns:a16="http://schemas.microsoft.com/office/drawing/2014/main" val="3271028071"/>
-                  </a:ext>
-                </a:extLst>
-              </a:tr>
-              <a:tr h="155737">
-                <a:tc>
-                  <a:txBody>
-                    <a:bodyPr/>
-                    <a:lstStyle/>
-                    <a:p>
-                      <a:pPr algn="r" fontAlgn="b"/>
-                      <a:r>
-                        <a:rPr lang="en-US" sz="1100" b="1" i="0" u="none" strike="noStrike" dirty="0">
-                          <a:solidFill>
-                            <a:schemeClr val="accent5">
-                              <a:lumMod val="50000"/>
-                            </a:schemeClr>
-                          </a:solidFill>
-                          <a:effectLst/>
-                          <a:latin typeface="Calibri" panose="020F0502020204030204" pitchFamily="34" charset="0"/>
-                        </a:rPr>
-                        <a:t>{persentase_vis_26_30}</a:t>
-                      </a:r>
-                    </a:p>
-                  </a:txBody>
-                  <a:tcPr marL="7620" marR="7620" marT="0" marB="0" anchor="b">
-                    <a:lnL w="12700" cmpd="sng">
-                      <a:noFill/>
-                      <a:prstDash val="solid"/>
-                    </a:lnL>
-                    <a:lnR w="12700" cmpd="sng">
-                      <a:noFill/>
-                      <a:prstDash val="solid"/>
-                    </a:lnR>
-                    <a:lnT w="12700" cmpd="sng">
-                      <a:noFill/>
-                      <a:prstDash val="solid"/>
-                    </a:lnT>
-                    <a:lnB w="12700" cmpd="sng">
-                      <a:noFill/>
-                      <a:prstDash val="solid"/>
-                    </a:lnB>
-                    <a:lnTlToBr w="12700" cmpd="sng">
-                      <a:noFill/>
-                      <a:prstDash val="solid"/>
-                    </a:lnTlToBr>
-                    <a:lnBlToTr w="12700" cmpd="sng">
-                      <a:noFill/>
-                      <a:prstDash val="solid"/>
-                    </a:lnBlToTr>
-                  </a:tcPr>
-                </a:tc>
-                <a:extLst>
-                  <a:ext uri="{0D108BD9-81ED-4DB2-BD59-A6C34878D82A}">
-                    <a16:rowId xmlns:a16="http://schemas.microsoft.com/office/drawing/2014/main" val="510083421"/>
-                  </a:ext>
-                </a:extLst>
-              </a:tr>
-              <a:tr h="155737">
-                <a:tc>
-                  <a:txBody>
-                    <a:bodyPr/>
-                    <a:lstStyle/>
-                    <a:p>
-                      <a:pPr algn="r" fontAlgn="b"/>
-                      <a:r>
-                        <a:rPr lang="en-US" sz="1100" b="1" i="0" u="none" strike="noStrike" dirty="0">
-                          <a:solidFill>
-                            <a:schemeClr val="accent5">
-                              <a:lumMod val="50000"/>
-                            </a:schemeClr>
-                          </a:solidFill>
-                          <a:effectLst/>
-                          <a:latin typeface="Calibri" panose="020F0502020204030204" pitchFamily="34" charset="0"/>
-                        </a:rPr>
-                        <a:t>{persentase_vis_30}</a:t>
-                      </a:r>
-                    </a:p>
-                  </a:txBody>
-                  <a:tcPr marL="7620" marR="7620" marT="0" marB="0" anchor="b">
-                    <a:lnL w="12700" cmpd="sng">
-                      <a:noFill/>
-                      <a:prstDash val="solid"/>
-                    </a:lnL>
-                    <a:lnR w="12700" cmpd="sng">
-                      <a:noFill/>
-                      <a:prstDash val="solid"/>
-                    </a:lnR>
-                    <a:lnT w="12700" cmpd="sng">
-                      <a:noFill/>
-                      <a:prstDash val="solid"/>
-                    </a:lnT>
-                    <a:lnB w="12700" cmpd="sng">
-                      <a:noFill/>
-                      <a:prstDash val="solid"/>
-                    </a:lnB>
-                    <a:lnTlToBr w="12700" cmpd="sng">
-                      <a:noFill/>
-                      <a:prstDash val="solid"/>
-                    </a:lnTlToBr>
-                    <a:lnBlToTr w="12700" cmpd="sng">
-                      <a:noFill/>
-                      <a:prstDash val="solid"/>
-                    </a:lnBlToTr>
-                  </a:tcPr>
-                </a:tc>
-                <a:extLst>
-                  <a:ext uri="{0D108BD9-81ED-4DB2-BD59-A6C34878D82A}">
-                    <a16:rowId xmlns:a16="http://schemas.microsoft.com/office/drawing/2014/main" val="3778675659"/>
-                  </a:ext>
-                </a:extLst>
-              </a:tr>
-            </a:tbl>
-          </a:graphicData>
-        </a:graphic>
-      </p:graphicFrame>
-      <p:graphicFrame>
-        <p:nvGraphicFramePr>
-          <p:cNvPr id="4" name="table_4">
-            <a:extLst>
-              <a:ext uri="{FF2B5EF4-FFF2-40B4-BE49-F238E27FC236}">
-                <a16:creationId xmlns:a16="http://schemas.microsoft.com/office/drawing/2014/main" id="{156096E4-3ED1-497D-AD93-67B2ACE69A01}"/>
-              </a:ext>
-            </a:extLst>
-          </p:cNvPr>
-          <p:cNvGraphicFramePr>
-            <a:graphicFrameLocks noGrp="1"/>
-          </p:cNvGraphicFramePr>
-          <p:nvPr>
-            <p:extLst>
-              <p:ext uri="{D42A27DB-BD31-4B8C-83A1-F6EECF244321}">
-                <p14:modId xmlns:p14="http://schemas.microsoft.com/office/powerpoint/2010/main" val="808520475"/>
-              </p:ext>
-            </p:extLst>
-          </p:nvPr>
-        </p:nvGraphicFramePr>
-        <p:xfrm>
-          <a:off x="4063202" y="3183032"/>
-          <a:ext cx="609600" cy="2331720"/>
-        </p:xfrm>
-        <a:graphic>
-          <a:graphicData uri="http://schemas.openxmlformats.org/drawingml/2006/table">
-            <a:tbl>
-              <a:tblPr>
-                <a:tableStyleId>{2460487B-A31E-4291-9FF1-7AE1C1612F53}</a:tableStyleId>
-              </a:tblPr>
-              <a:tblGrid>
-                <a:gridCol w="609600">
-                  <a:extLst>
-                    <a:ext uri="{9D8B030D-6E8A-4147-A177-3AD203B41FA5}">
-                      <a16:colId xmlns:a16="http://schemas.microsoft.com/office/drawing/2014/main" val="1167015549"/>
-                    </a:ext>
-                  </a:extLst>
-                </a:gridCol>
-              </a:tblGrid>
-              <a:tr h="196535">
-                <a:tc>
-                  <a:txBody>
-                    <a:bodyPr/>
-                    <a:lstStyle/>
-                    <a:p>
-                      <a:pPr algn="r" fontAlgn="b"/>
-                      <a:r>
-                        <a:rPr lang="en-US" sz="1000" b="1" i="0" u="none" strike="noStrike" dirty="0">
-                          <a:solidFill>
-                            <a:schemeClr val="accent5">
-                              <a:lumMod val="50000"/>
-                            </a:schemeClr>
-                          </a:solidFill>
-                          <a:effectLst/>
-                          <a:latin typeface="Calibri" panose="020F0502020204030204" pitchFamily="34" charset="0"/>
-                        </a:rPr>
-                        <a:t>{persentase_vis_18}</a:t>
-                      </a:r>
-                    </a:p>
-                  </a:txBody>
-                  <a:tcPr marL="7620" marR="7620" marT="7620" marB="0" anchor="ctr">
-                    <a:lnL w="12700" cap="flat" cmpd="sng" algn="ctr">
-                      <a:noFill/>
-                      <a:prstDash val="solid"/>
-                      <a:round/>
-                      <a:headEnd type="none" w="med" len="med"/>
-                      <a:tailEnd type="none" w="med" len="med"/>
-                    </a:lnL>
-                    <a:lnR w="12700" cap="flat" cmpd="sng" algn="ctr">
-                      <a:noFill/>
-                      <a:prstDash val="solid"/>
-                      <a:round/>
-                      <a:headEnd type="none" w="med" len="med"/>
-                      <a:tailEnd type="none" w="med" len="med"/>
-                    </a:lnR>
-                    <a:lnT w="12700" cap="flat" cmpd="sng" algn="ctr">
-                      <a:noFill/>
-                      <a:prstDash val="solid"/>
-                      <a:round/>
-                      <a:headEnd type="none" w="med" len="med"/>
-                      <a:tailEnd type="none" w="med" len="med"/>
-                    </a:lnT>
-                    <a:lnB w="12700" cap="flat" cmpd="sng" algn="ctr">
-                      <a:noFill/>
-                      <a:prstDash val="solid"/>
-                      <a:round/>
-                      <a:headEnd type="none" w="med" len="med"/>
-                      <a:tailEnd type="none" w="med" len="med"/>
-                    </a:lnB>
-                    <a:lnTlToBr w="12700" cmpd="sng">
-                      <a:noFill/>
-                      <a:prstDash val="solid"/>
-                    </a:lnTlToBr>
-                    <a:lnBlToTr w="12700" cmpd="sng">
-                      <a:noFill/>
-                      <a:prstDash val="solid"/>
-                    </a:lnBlToTr>
-                  </a:tcPr>
-                </a:tc>
-                <a:extLst>
-                  <a:ext uri="{0D108BD9-81ED-4DB2-BD59-A6C34878D82A}">
-                    <a16:rowId xmlns:a16="http://schemas.microsoft.com/office/drawing/2014/main" val="3870194963"/>
-                  </a:ext>
-                </a:extLst>
-              </a:tr>
-              <a:tr h="196535">
-                <a:tc>
-                  <a:txBody>
-                    <a:bodyPr/>
-                    <a:lstStyle/>
-                    <a:p>
-                      <a:pPr algn="r" fontAlgn="b"/>
-                      <a:r>
-                        <a:rPr lang="en-US" sz="1000" b="1" u="none" strike="noStrike" dirty="0">
-                          <a:solidFill>
-                            <a:schemeClr val="accent5">
-                              <a:lumMod val="50000"/>
-                            </a:schemeClr>
-                          </a:solidFill>
-                          <a:effectLst/>
-                        </a:rPr>
-                        <a:t>{persentase_vis_21}</a:t>
-                      </a:r>
-                      <a:endParaRPr lang="en-US" sz="1000" b="1" i="0" u="none" strike="noStrike" dirty="0">
-                        <a:solidFill>
-                          <a:schemeClr val="accent5">
-                            <a:lumMod val="50000"/>
-                          </a:schemeClr>
-                        </a:solidFill>
-                        <a:effectLst/>
-                        <a:latin typeface="Calibri" panose="020F0502020204030204" pitchFamily="34" charset="0"/>
-                      </a:endParaRPr>
-                    </a:p>
-                  </a:txBody>
-                  <a:tcPr marL="7620" marR="7620" marT="7620" marB="0" anchor="ctr">
-                    <a:lnL w="12700" cap="flat" cmpd="sng" algn="ctr">
-                      <a:noFill/>
-                      <a:prstDash val="solid"/>
-                      <a:round/>
-                      <a:headEnd type="none" w="med" len="med"/>
-                      <a:tailEnd type="none" w="med" len="med"/>
-                    </a:lnL>
-                    <a:lnR w="12700" cap="flat" cmpd="sng" algn="ctr">
-                      <a:noFill/>
-                      <a:prstDash val="solid"/>
-                      <a:round/>
-                      <a:headEnd type="none" w="med" len="med"/>
-                      <a:tailEnd type="none" w="med" len="med"/>
-                    </a:lnR>
-                    <a:lnT w="12700" cap="flat" cmpd="sng" algn="ctr">
-                      <a:noFill/>
-                      <a:prstDash val="solid"/>
-                      <a:round/>
-                      <a:headEnd type="none" w="med" len="med"/>
-                      <a:tailEnd type="none" w="med" len="med"/>
-                    </a:lnT>
-                    <a:lnB w="12700" cap="flat" cmpd="sng" algn="ctr">
-                      <a:noFill/>
-                      <a:prstDash val="solid"/>
-                      <a:round/>
-                      <a:headEnd type="none" w="med" len="med"/>
-                      <a:tailEnd type="none" w="med" len="med"/>
-                    </a:lnB>
-                    <a:lnTlToBr w="12700" cmpd="sng">
-                      <a:noFill/>
-                      <a:prstDash val="solid"/>
-                    </a:lnTlToBr>
-                    <a:lnBlToTr w="12700" cmpd="sng">
-                      <a:noFill/>
-                      <a:prstDash val="solid"/>
-                    </a:lnBlToTr>
-                  </a:tcPr>
-                </a:tc>
-                <a:extLst>
-                  <a:ext uri="{0D108BD9-81ED-4DB2-BD59-A6C34878D82A}">
-                    <a16:rowId xmlns:a16="http://schemas.microsoft.com/office/drawing/2014/main" val="1515045056"/>
-                  </a:ext>
-                </a:extLst>
-              </a:tr>
-              <a:tr h="200891">
-                <a:tc>
-                  <a:txBody>
-                    <a:bodyPr/>
-                    <a:lstStyle/>
-                    <a:p>
-                      <a:pPr algn="r" fontAlgn="b"/>
-                      <a:r>
-                        <a:rPr lang="en-US" sz="1000" b="1" i="0" u="none" strike="noStrike" dirty="0">
-                          <a:solidFill>
-                            <a:schemeClr val="accent5">
-                              <a:lumMod val="50000"/>
-                            </a:schemeClr>
-                          </a:solidFill>
-                          <a:effectLst/>
-                          <a:latin typeface="Calibri" panose="020F0502020204030204" pitchFamily="34" charset="0"/>
-                        </a:rPr>
-                        <a:t>{persentase_vis_31}</a:t>
-                      </a:r>
-                    </a:p>
-                  </a:txBody>
-                  <a:tcPr marL="7620" marR="7620" marT="7620" marB="0" anchor="ctr">
-                    <a:lnL w="12700" cap="flat" cmpd="sng" algn="ctr">
-                      <a:noFill/>
-                      <a:prstDash val="solid"/>
-                      <a:round/>
-                      <a:headEnd type="none" w="med" len="med"/>
-                      <a:tailEnd type="none" w="med" len="med"/>
-                    </a:lnL>
-                    <a:lnR w="12700" cap="flat" cmpd="sng" algn="ctr">
-                      <a:noFill/>
-                      <a:prstDash val="solid"/>
-                      <a:round/>
-                      <a:headEnd type="none" w="med" len="med"/>
-                      <a:tailEnd type="none" w="med" len="med"/>
-                    </a:lnR>
-                    <a:lnT w="12700" cap="flat" cmpd="sng" algn="ctr">
-                      <a:noFill/>
-                      <a:prstDash val="solid"/>
-                      <a:round/>
-                      <a:headEnd type="none" w="med" len="med"/>
-                      <a:tailEnd type="none" w="med" len="med"/>
-                    </a:lnT>
-                    <a:lnB w="12700" cap="flat" cmpd="sng" algn="ctr">
-                      <a:noFill/>
-                      <a:prstDash val="solid"/>
-                      <a:round/>
-                      <a:headEnd type="none" w="med" len="med"/>
-                      <a:tailEnd type="none" w="med" len="med"/>
-                    </a:lnB>
-                    <a:lnTlToBr w="12700" cmpd="sng">
-                      <a:noFill/>
-                      <a:prstDash val="solid"/>
-                    </a:lnTlToBr>
-                    <a:lnBlToTr w="12700" cmpd="sng">
-                      <a:noFill/>
-                      <a:prstDash val="solid"/>
-                    </a:lnBlToTr>
-                  </a:tcPr>
-                </a:tc>
-                <a:extLst>
-                  <a:ext uri="{0D108BD9-81ED-4DB2-BD59-A6C34878D82A}">
-                    <a16:rowId xmlns:a16="http://schemas.microsoft.com/office/drawing/2014/main" val="3016878282"/>
-                  </a:ext>
-                </a:extLst>
-              </a:tr>
-              <a:tr h="180109">
-                <a:tc>
-                  <a:txBody>
-                    <a:bodyPr/>
-                    <a:lstStyle/>
-                    <a:p>
-                      <a:pPr algn="r" fontAlgn="b"/>
-                      <a:r>
-                        <a:rPr lang="en-US" sz="1000" b="1" i="0" u="none" strike="noStrike" dirty="0">
-                          <a:solidFill>
-                            <a:schemeClr val="accent5">
-                              <a:lumMod val="50000"/>
-                            </a:schemeClr>
-                          </a:solidFill>
-                          <a:effectLst/>
-                          <a:latin typeface="Calibri" panose="020F0502020204030204" pitchFamily="34" charset="0"/>
-                        </a:rPr>
-                        <a:t>{persentase_vis_41}</a:t>
-                      </a:r>
-                    </a:p>
-                  </a:txBody>
-                  <a:tcPr marL="7620" marR="7620" marT="7620" marB="0" anchor="ctr">
-                    <a:lnL w="12700" cap="flat" cmpd="sng" algn="ctr">
-                      <a:noFill/>
-                      <a:prstDash val="solid"/>
-                      <a:round/>
-                      <a:headEnd type="none" w="med" len="med"/>
-                      <a:tailEnd type="none" w="med" len="med"/>
-                    </a:lnL>
-                    <a:lnR w="12700" cap="flat" cmpd="sng" algn="ctr">
-                      <a:noFill/>
-                      <a:prstDash val="solid"/>
-                      <a:round/>
-                      <a:headEnd type="none" w="med" len="med"/>
-                      <a:tailEnd type="none" w="med" len="med"/>
-                    </a:lnR>
-                    <a:lnT w="12700" cap="flat" cmpd="sng" algn="ctr">
-                      <a:noFill/>
-                      <a:prstDash val="solid"/>
-                      <a:round/>
-                      <a:headEnd type="none" w="med" len="med"/>
-                      <a:tailEnd type="none" w="med" len="med"/>
-                    </a:lnT>
-                    <a:lnB w="12700" cap="flat" cmpd="sng" algn="ctr">
-                      <a:noFill/>
-                      <a:prstDash val="solid"/>
-                      <a:round/>
-                      <a:headEnd type="none" w="med" len="med"/>
-                      <a:tailEnd type="none" w="med" len="med"/>
-                    </a:lnB>
-                    <a:lnTlToBr w="12700" cmpd="sng">
-                      <a:noFill/>
-                      <a:prstDash val="solid"/>
-                    </a:lnTlToBr>
-                    <a:lnBlToTr w="12700" cmpd="sng">
-                      <a:noFill/>
-                      <a:prstDash val="solid"/>
-                    </a:lnBlToTr>
-                  </a:tcPr>
-                </a:tc>
-                <a:extLst>
-                  <a:ext uri="{0D108BD9-81ED-4DB2-BD59-A6C34878D82A}">
-                    <a16:rowId xmlns:a16="http://schemas.microsoft.com/office/drawing/2014/main" val="687605397"/>
-                  </a:ext>
-                </a:extLst>
-              </a:tr>
-              <a:tr h="207818">
-                <a:tc>
-                  <a:txBody>
-                    <a:bodyPr/>
-                    <a:lstStyle/>
-                    <a:p>
-                      <a:pPr algn="r" fontAlgn="b"/>
-                      <a:r>
-                        <a:rPr lang="en-US" sz="1000" b="1" i="0" u="none" strike="noStrike" dirty="0">
-                          <a:solidFill>
-                            <a:schemeClr val="accent5">
-                              <a:lumMod val="50000"/>
-                            </a:schemeClr>
-                          </a:solidFill>
-                          <a:effectLst/>
-                          <a:latin typeface="+mj-lt"/>
-                        </a:rPr>
-                        <a:t>{persentase_vis_51}</a:t>
-                      </a:r>
-                    </a:p>
-                  </a:txBody>
-                  <a:tcPr marL="7620" marR="7620" marT="7620" marB="0" anchor="ctr">
-                    <a:lnL w="12700" cap="flat" cmpd="sng" algn="ctr">
-                      <a:noFill/>
-                      <a:prstDash val="solid"/>
-                      <a:round/>
-                      <a:headEnd type="none" w="med" len="med"/>
-                      <a:tailEnd type="none" w="med" len="med"/>
-                    </a:lnL>
-                    <a:lnR w="12700" cap="flat" cmpd="sng" algn="ctr">
-                      <a:noFill/>
-                      <a:prstDash val="solid"/>
-                      <a:round/>
-                      <a:headEnd type="none" w="med" len="med"/>
-                      <a:tailEnd type="none" w="med" len="med"/>
-                    </a:lnR>
-                    <a:lnT w="12700" cap="flat" cmpd="sng" algn="ctr">
-                      <a:noFill/>
-                      <a:prstDash val="solid"/>
-                      <a:round/>
-                      <a:headEnd type="none" w="med" len="med"/>
-                      <a:tailEnd type="none" w="med" len="med"/>
-                    </a:lnT>
-                    <a:lnB w="12700" cap="flat" cmpd="sng" algn="ctr">
-                      <a:noFill/>
-                      <a:prstDash val="solid"/>
-                      <a:round/>
-                      <a:headEnd type="none" w="med" len="med"/>
-                      <a:tailEnd type="none" w="med" len="med"/>
-                    </a:lnB>
-                    <a:lnTlToBr w="12700" cmpd="sng">
-                      <a:noFill/>
-                      <a:prstDash val="solid"/>
-                    </a:lnTlToBr>
-                    <a:lnBlToTr w="12700" cmpd="sng">
-                      <a:noFill/>
-                      <a:prstDash val="solid"/>
-                    </a:lnBlToTr>
-                  </a:tcPr>
-                </a:tc>
-                <a:extLst>
-                  <a:ext uri="{0D108BD9-81ED-4DB2-BD59-A6C34878D82A}">
-                    <a16:rowId xmlns:a16="http://schemas.microsoft.com/office/drawing/2014/main" val="3247638504"/>
-                  </a:ext>
-                </a:extLst>
-              </a:tr>
-              <a:tr h="180109">
-                <a:tc>
-                  <a:txBody>
-                    <a:bodyPr/>
-                    <a:lstStyle/>
-                    <a:p>
-                      <a:pPr algn="r" fontAlgn="b"/>
-                      <a:r>
-                        <a:rPr lang="en-US" sz="1000" b="1" i="0" u="none" strike="noStrike" dirty="0">
-                          <a:solidFill>
-                            <a:schemeClr val="accent5">
-                              <a:lumMod val="50000"/>
-                            </a:schemeClr>
-                          </a:solidFill>
-                          <a:effectLst/>
-                          <a:latin typeface="+mj-lt"/>
-                        </a:rPr>
-                        <a:t>{persentase_vis_60}</a:t>
-                      </a:r>
-                    </a:p>
-                  </a:txBody>
-                  <a:tcPr marL="7620" marR="7620" marT="7620" marB="0" anchor="ctr">
-                    <a:lnL w="12700" cap="flat" cmpd="sng" algn="ctr">
-                      <a:noFill/>
-                      <a:prstDash val="solid"/>
-                      <a:round/>
-                      <a:headEnd type="none" w="med" len="med"/>
-                      <a:tailEnd type="none" w="med" len="med"/>
-                    </a:lnL>
-                    <a:lnR w="12700" cap="flat" cmpd="sng" algn="ctr">
-                      <a:noFill/>
-                      <a:prstDash val="solid"/>
-                      <a:round/>
-                      <a:headEnd type="none" w="med" len="med"/>
-                      <a:tailEnd type="none" w="med" len="med"/>
-                    </a:lnR>
-                    <a:lnT w="12700" cap="flat" cmpd="sng" algn="ctr">
-                      <a:noFill/>
-                      <a:prstDash val="solid"/>
-                      <a:round/>
-                      <a:headEnd type="none" w="med" len="med"/>
-                      <a:tailEnd type="none" w="med" len="med"/>
-                    </a:lnT>
-                    <a:lnB w="12700" cap="flat" cmpd="sng" algn="ctr">
-                      <a:noFill/>
-                      <a:prstDash val="solid"/>
-                      <a:round/>
-                      <a:headEnd type="none" w="med" len="med"/>
-                      <a:tailEnd type="none" w="med" len="med"/>
-                    </a:lnB>
-                    <a:lnTlToBr w="12700" cmpd="sng">
-                      <a:noFill/>
-                      <a:prstDash val="solid"/>
-                    </a:lnTlToBr>
-                    <a:lnBlToTr w="12700" cmpd="sng">
-                      <a:noFill/>
-                      <a:prstDash val="solid"/>
-                    </a:lnBlToTr>
-                  </a:tcPr>
-                </a:tc>
-                <a:extLst>
-                  <a:ext uri="{0D108BD9-81ED-4DB2-BD59-A6C34878D82A}">
-                    <a16:rowId xmlns:a16="http://schemas.microsoft.com/office/drawing/2014/main" val="864016896"/>
-                  </a:ext>
-                </a:extLst>
-              </a:tr>
-            </a:tbl>
-          </a:graphicData>
-        </a:graphic>
-      </p:graphicFrame>
       <p:sp>
         <p:nvSpPr>
           <p:cNvPr id="11" name="TextBox 10">
@@ -23881,6 +20022,53 @@
           </a:p>
         </p:txBody>
       </p:sp>
+      <p:pic>
+        <p:nvPicPr>
+          <p:cNvPr id="1028" name="Picture 4">
+            <a:extLst>
+              <a:ext uri="{FF2B5EF4-FFF2-40B4-BE49-F238E27FC236}">
+                <a16:creationId xmlns:a16="http://schemas.microsoft.com/office/drawing/2014/main" id="{B16B8D91-F850-AE19-146D-8F4F98A1E203}"/>
+              </a:ext>
+            </a:extLst>
+          </p:cNvPr>
+          <p:cNvPicPr>
+            <a:picLocks noChangeAspect="1" noChangeArrowheads="1"/>
+          </p:cNvPicPr>
+          <p:nvPr/>
+        </p:nvPicPr>
+        <p:blipFill>
+          <a:blip r:embed="rId10">
+            <a:extLst>
+              <a:ext uri="{28A0092B-C50C-407E-A947-70E740481C1C}">
+                <a14:useLocalDpi xmlns:a14="http://schemas.microsoft.com/office/drawing/2010/main" val="0"/>
+              </a:ext>
+            </a:extLst>
+          </a:blip>
+          <a:srcRect/>
+          <a:stretch>
+            <a:fillRect/>
+          </a:stretch>
+        </p:blipFill>
+        <p:spPr bwMode="auto">
+          <a:xfrm>
+            <a:off x="7763598" y="3639703"/>
+            <a:ext cx="1245555" cy="1080913"/>
+          </a:xfrm>
+          <a:prstGeom prst="rect">
+            <a:avLst/>
+          </a:prstGeom>
+          <a:noFill/>
+          <a:extLst>
+            <a:ext uri="{909E8E84-426E-40DD-AFC4-6F175D3DCCD1}">
+              <a14:hiddenFill xmlns:a14="http://schemas.microsoft.com/office/drawing/2010/main">
+                <a:solidFill>
+                  <a:srgbClr val="FFFFFF"/>
+                </a:solidFill>
+              </a14:hiddenFill>
+            </a:ext>
+          </a:extLst>
+        </p:spPr>
+      </p:pic>
     </p:spTree>
   </p:cSld>
   <p:clrMapOvr>

</xml_diff>

<commit_message>
On branch main  Your branch is up to date with 'origin/main'.  Changes to be committed: 	new file:   automation/filter.py 	modified:   dataconfig/data.py 	modified:   dataconfig/mapping.py 	modified:   main.py 	modified:   template/query_templates.py 	modified:   template/template_infografis.pptx 	new file:   tutorial.txt
</commit_message>
<xml_diff>
--- a/template/template_infografis.pptx
+++ b/template/template_infografis.pptx
@@ -19772,8 +19772,8 @@
         </p:nvSpPr>
         <p:spPr>
           <a:xfrm>
-            <a:off x="6519439" y="3338154"/>
-            <a:ext cx="517698" cy="461665"/>
+            <a:off x="6443054" y="3338154"/>
+            <a:ext cx="594083" cy="461665"/>
           </a:xfrm>
           <a:prstGeom prst="rect">
             <a:avLst/>
@@ -19860,8 +19860,8 @@
         </p:nvSpPr>
         <p:spPr>
           <a:xfrm>
-            <a:off x="5171381" y="3338153"/>
-            <a:ext cx="517698" cy="461665"/>
+            <a:off x="5130094" y="3338153"/>
+            <a:ext cx="558985" cy="461665"/>
           </a:xfrm>
           <a:prstGeom prst="rect">
             <a:avLst/>
@@ -19948,8 +19948,8 @@
         </p:nvSpPr>
         <p:spPr>
           <a:xfrm>
-            <a:off x="7906850" y="3338153"/>
-            <a:ext cx="517698" cy="461665"/>
+            <a:off x="7857008" y="3338153"/>
+            <a:ext cx="567540" cy="461665"/>
           </a:xfrm>
           <a:prstGeom prst="rect">
             <a:avLst/>

</xml_diff>